<commit_message>
Reposiciona SR1 estrategicamente + renumera sprints (sem Sprint 0)
- Slide 4 reescrito com manifesto ("Observatório-de-portfólio para
  consultoria") + 3 diferenciais (vs. PM tools, vs. BI, vs. acadêmicos),
  substituindo descrição rasa por visão de produto
- Slide 6: caixa Plano B removida
- Slide 7: título "Sprint 0" trocado por "Status atual e próximas semanas"
- Sprints renumeradas 1→5 (preparatória vira Sprint 1) em backlog e plano
- Removidas todas as menções a "pivot" nos slides
- Fix em duplicate_slide (pptx_helpers): pictures duplicadas via deepcopy
  agora são re-criadas com bytes para preservar r:embed (logo no slide 4)

Co-Authored-By: Claude Opus 4.7 (1M context) <noreply@anthropic.com>
</commit_message>
<xml_diff>
--- a/atividades/apresentacoes/sr1_2026-05-22.pptx
+++ b/atividades/apresentacoes/sr1_2026-05-22.pptx
@@ -8,6 +8,7 @@
     <p:sldId id="256" r:id="rId7"/>
     <p:sldId id="257" r:id="rId8"/>
     <p:sldId id="259" r:id="rId10"/>
+    <p:sldId id="275" r:id="rId14"/>
     <p:sldId id="264" r:id="rId15"/>
     <p:sldId id="270" r:id="rId21"/>
     <p:sldId id="273" r:id="rId24"/>
@@ -3233,7 +3234,7 @@
                 </a:solidFill>
                 <a:latin typeface="Arial"/>
               </a:rPr>
-              <a:t>ObiOne · Observatório-Comunidade de Projetos</a:t>
+              <a:t>ObiOne · Observatório de Projetos</a:t>
             </a:r>
           </a:p>
         </p:txBody>
@@ -3268,7 +3269,7 @@
                 </a:solidFill>
                 <a:latin typeface="Arial"/>
               </a:rPr>
-              <a:t>Apresentação à cadeira TAES</a:t>
+              <a:t>Apresentação à cadeira Tópicos Avançados em Engenharia de Software</a:t>
             </a:r>
           </a:p>
         </p:txBody>
@@ -3381,7 +3382,7 @@
                 </a:solidFill>
                 <a:latin typeface="Arial"/>
               </a:rPr>
-              <a:t>Bruno Rocha · Cynthia Oliveira · Moisés Júnior · Raniel Silva (apresentador)</a:t>
+              <a:t>Bruno Rocha · Cynthia Oliveira · Moisés Júnior · Raniel Silva</a:t>
             </a:r>
           </a:p>
         </p:txBody>
@@ -3452,41 +3453,6 @@
                 <a:latin typeface="Arial"/>
               </a:rPr>
               <a:t>Prof. Ivaldir Honório de Farias Júnior</a:t>
-            </a:r>
-          </a:p>
-        </p:txBody>
-      </p:sp>
-      <p:sp>
-        <p:nvSpPr>
-          <p:cNvPr id="12" name="TextBox 11"/>
-          <p:cNvSpPr txBox="1"/>
-          <p:nvPr/>
-        </p:nvSpPr>
-        <p:spPr>
-          <a:xfrm>
-            <a:off x="685800" y="6080760"/>
-            <a:ext cx="11000000" cy="228600"/>
-          </a:xfrm>
-          <a:prstGeom prst="rect">
-            <a:avLst/>
-          </a:prstGeom>
-          <a:noFill/>
-        </p:spPr>
-        <p:txBody>
-          <a:bodyPr wrap="square" lIns="0" rIns="0" tIns="0" bIns="0" anchor="t">
-            <a:spAutoFit/>
-          </a:bodyPr>
-          <a:lstStyle/>
-          <a:p>
-            <a:pPr algn="l"/>
-            <a:r>
-              <a:rPr sz="1100" b="0" i="0">
-                <a:solidFill>
-                  <a:srgbClr val="4A4A5A"/>
-                </a:solidFill>
-                <a:latin typeface="Arial"/>
-              </a:rPr>
-              <a:t>Doutorado PPGEC · Tópicos Avançados em Engenharia de Software</a:t>
             </a:r>
           </a:p>
         </p:txBody>
@@ -3832,7 +3798,7 @@
                 </a:solidFill>
                 <a:latin typeface="Arial"/>
               </a:rPr>
-              <a:t>O escopo</a:t>
+              <a:t>Contexto</a:t>
             </a:r>
           </a:p>
         </p:txBody>
@@ -3867,7 +3833,7 @@
                 </a:solidFill>
                 <a:latin typeface="Arial"/>
               </a:rPr>
-              <a:t>O que vamos construir</a:t>
+              <a:t>Por que um observatório vivo</a:t>
             </a:r>
           </a:p>
         </p:txBody>
@@ -3980,7 +3946,7 @@
                 </a:solidFill>
                 <a:latin typeface="Arial"/>
               </a:rPr>
-              <a:t>Onde estamos</a:t>
+              <a:t>O escopo</a:t>
             </a:r>
           </a:p>
         </p:txBody>
@@ -4015,7 +3981,7 @@
                 </a:solidFill>
                 <a:latin typeface="Arial"/>
               </a:rPr>
-              <a:t>Sprint 0 em curso</a:t>
+              <a:t>O que vamos construir</a:t>
             </a:r>
           </a:p>
         </p:txBody>
@@ -4128,7 +4094,7 @@
                 </a:solidFill>
                 <a:latin typeface="Arial"/>
               </a:rPr>
-              <a:t>Onde chegaremos</a:t>
+              <a:t>Cronograma</a:t>
             </a:r>
           </a:p>
         </p:txBody>
@@ -4163,7 +4129,7 @@
                 </a:solidFill>
                 <a:latin typeface="Arial"/>
               </a:rPr>
-              <a:t>Cronograma e marcos</a:t>
+              <a:t>9 semanas · 4 marcos</a:t>
             </a:r>
           </a:p>
         </p:txBody>
@@ -4276,7 +4242,7 @@
                 </a:solidFill>
                 <a:latin typeface="Arial"/>
               </a:rPr>
-              <a:t>Próximos passos</a:t>
+              <a:t>Status atual</a:t>
             </a:r>
           </a:p>
         </p:txBody>
@@ -4311,7 +4277,7 @@
                 </a:solidFill>
                 <a:latin typeface="Arial"/>
               </a:rPr>
-              <a:t>Sprint 1 e riscos</a:t>
+              <a:t>Onde estamos e o que vem</a:t>
             </a:r>
           </a:p>
         </p:txBody>
@@ -4475,7 +4441,7 @@
                 </a:solidFill>
                 <a:latin typeface="Arial"/>
               </a:rPr>
-              <a:t>Equipe ObiOne · Doutorado PPGEC · UPE/POLI · Maio 2026</a:t>
+              <a:t>Equipe ObiOne · UPE/POLI · Maio 2026</a:t>
             </a:r>
           </a:p>
         </p:txBody>
@@ -4510,7 +4476,7 @@
                 </a:solidFill>
                 <a:latin typeface="Arial"/>
               </a:rPr>
-              <a:t>2 / 7</a:t>
+              <a:t>2 / 8</a:t>
             </a:r>
           </a:p>
         </p:txBody>
@@ -4595,7 +4561,7 @@
                 </a:solidFill>
                 <a:latin typeface="Arial"/>
               </a:rPr>
-              <a:t>O QUE PROPOMOS</a:t>
+              <a:t>CONTEXTO</a:t>
             </a:r>
           </a:p>
         </p:txBody>
@@ -4630,7 +4596,7 @@
                 </a:solidFill>
                 <a:latin typeface="Arial"/>
               </a:rPr>
-              <a:t>Observatório-comunidade baseado no MPO</a:t>
+              <a:t>Observatório é mais que dashboard</a:t>
             </a:r>
           </a:p>
         </p:txBody>
@@ -4753,7 +4719,7 @@
                 </a:solidFill>
                 <a:latin typeface="Arial"/>
               </a:rPr>
-              <a:t>O QUE VAMOS CONSTRUIR</a:t>
+              <a:t>OBSERVATÓRIOS VS. FERRAMENTAS</a:t>
             </a:r>
           </a:p>
         </p:txBody>
@@ -4788,7 +4754,7 @@
                 </a:solidFill>
                 <a:latin typeface="Arial"/>
               </a:rPr>
-              <a:t>Três camadas integradas</a:t>
+              <a:t>Comunidade ativa de múltiplos atores</a:t>
             </a:r>
           </a:p>
           <a:p>
@@ -4816,7 +4782,7 @@
                 </a:solidFill>
                 <a:latin typeface="Arial"/>
               </a:rPr>
-              <a:t>Pipeline LLM extrai os atributos do Quadro 37 do MPO de documentos .docx não-estruturados.</a:t>
+              <a:t>Um observatório é espaço de conhecimento entre consultoria, clientes e pesquisa, mediado por interação contínua.</a:t>
             </a:r>
           </a:p>
           <a:p>
@@ -4832,7 +4798,7 @@
                 </a:solidFill>
                 <a:latin typeface="Arial"/>
               </a:rPr>
-              <a:t>Comunidade semi-aberta: consultoria curatoriza e cada cliente acessa apenas o seu projeto, com comentários e feed in-app.</a:t>
+              <a:t>Ferramentas de gestão oferecem visualização do status. Faltam o tecido social e a curadoria do conhecimento.</a:t>
             </a:r>
           </a:p>
           <a:p>
@@ -4844,7 +4810,7 @@
                 </a:solidFill>
                 <a:latin typeface="Arial"/>
               </a:rPr>
-              <a:t>IA-Assistente reduz fricção operacional: gera resumo para o cliente e drafts para o consultor revisar.</a:t>
+              <a:t>Resultado: observatórios reais são raros porque mantê-los vivos custa caro.</a:t>
             </a:r>
           </a:p>
         </p:txBody>
@@ -4967,7 +4933,7 @@
                 </a:solidFill>
                 <a:latin typeface="Arial"/>
               </a:rPr>
-              <a:t>FUNDAMENTAÇÃO MPO</a:t>
+              <a:t>POR QUE É CARO?</a:t>
             </a:r>
           </a:p>
         </p:txBody>
@@ -5002,7 +4968,7 @@
                 </a:solidFill>
                 <a:latin typeface="Arial"/>
               </a:rPr>
-              <a:t>Endereçando lacunas do Vieira (2022)</a:t>
+              <a:t>Três fontes de fricção</a:t>
             </a:r>
           </a:p>
         </p:txBody>
@@ -5037,7 +5003,7 @@
                 </a:solidFill>
                 <a:latin typeface="Arial"/>
               </a:rPr>
-              <a:t>3 / 7</a:t>
+              <a:t>Manual</a:t>
             </a:r>
           </a:p>
         </p:txBody>
@@ -5072,7 +5038,7 @@
                 </a:solidFill>
                 <a:latin typeface="Arial"/>
               </a:rPr>
-              <a:t>atributos do Quadro 37 cobertos</a:t>
+              <a:t>curadoria de atributos do projeto</a:t>
             </a:r>
           </a:p>
         </p:txBody>
@@ -5107,7 +5073,7 @@
                 </a:solidFill>
                 <a:latin typeface="Arial"/>
               </a:rPr>
-              <a:t>8 categorias do MPO (geral, escopo, riscos, lições, etc.)</a:t>
+              <a:t>ler documentos, estruturar, atualizar</a:t>
             </a:r>
           </a:p>
         </p:txBody>
@@ -5142,7 +5108,7 @@
                 </a:solidFill>
                 <a:latin typeface="Arial"/>
               </a:rPr>
-              <a:t>5 reais</a:t>
+              <a:t>Repetitivo</a:t>
             </a:r>
           </a:p>
         </p:txBody>
@@ -5177,7 +5143,7 @@
                 </a:solidFill>
                 <a:latin typeface="Arial"/>
               </a:rPr>
-              <a:t>projetos do estudo de caso</a:t>
+              <a:t>comunicar progresso aos clientes</a:t>
             </a:r>
           </a:p>
         </p:txBody>
@@ -5212,7 +5178,7 @@
                 </a:solidFill>
                 <a:latin typeface="Arial"/>
               </a:rPr>
-              <a:t>jurídico · saúde · esporte · branding</a:t>
+              <a:t>traduzir técnico em narrativa acessível</a:t>
             </a:r>
           </a:p>
         </p:txBody>
@@ -5247,7 +5213,7 @@
                 </a:solidFill>
                 <a:latin typeface="Arial"/>
               </a:rPr>
-              <a:t>3 TF</a:t>
+              <a:t>Custoso</a:t>
             </a:r>
           </a:p>
         </p:txBody>
@@ -5282,7 +5248,7 @@
                 </a:solidFill>
                 <a:latin typeface="Arial"/>
               </a:rPr>
-              <a:t>Trabalhos Futuros endereçados</a:t>
+              <a:t>manter engajamento da comunidade</a:t>
             </a:r>
           </a:p>
         </p:txBody>
@@ -5317,7 +5283,7 @@
                 </a:solidFill>
                 <a:latin typeface="Arial"/>
               </a:rPr>
-              <a:t>#4 Interatividade · #7 Comparativos · #8 Soluções computacionais</a:t>
+              <a:t>responder, contextualizar, sugerir próximos passos</a:t>
             </a:r>
           </a:p>
         </p:txBody>
@@ -5352,7 +5318,7 @@
                 </a:solidFill>
                 <a:latin typeface="Arial"/>
               </a:rPr>
-              <a:t>Diferencial: tecido social que materializa as características Interatividade e Rede de Colaboração do MPO.</a:t>
+              <a:t>Sem reduzir essa fricção, o observatório fica restrito à teoria. É aí que entra a IA Generativa.</a:t>
             </a:r>
           </a:p>
         </p:txBody>
@@ -5430,7 +5396,7 @@
                 </a:solidFill>
                 <a:latin typeface="Arial"/>
               </a:rPr>
-              <a:t>Fonte: Vieira (2022) · Quadro 37 (p. 264)</a:t>
+              <a:t>Fonte: Vieira (2022) · Cap. 5 (MPO)</a:t>
             </a:r>
           </a:p>
         </p:txBody>
@@ -5465,7 +5431,7 @@
                 </a:solidFill>
                 <a:latin typeface="Arial"/>
               </a:rPr>
-              <a:t>Fonte: 5 projetos reais em contexto/projetos/</a:t>
+              <a:t>Fonte: OPTI-PE como caso prático</a:t>
             </a:r>
           </a:p>
         </p:txBody>
@@ -5500,7 +5466,7 @@
                 </a:solidFill>
                 <a:latin typeface="Arial"/>
               </a:rPr>
-              <a:t>Fonte: Vieira (2022) · Seção 6.4 (pp. 215-217)</a:t>
+              <a:t>Fonte: Vieira (2022) · Seção 6.4 · Trabalhos Futuros</a:t>
             </a:r>
           </a:p>
         </p:txBody>
@@ -5578,7 +5544,7 @@
                 </a:solidFill>
                 <a:latin typeface="Arial"/>
               </a:rPr>
-              <a:t>Equipe ObiOne · Doutorado PPGEC · UPE/POLI · Maio 2026</a:t>
+              <a:t>Equipe ObiOne · UPE/POLI · Maio 2026</a:t>
             </a:r>
           </a:p>
         </p:txBody>
@@ -5613,7 +5579,7 @@
                 </a:solidFill>
                 <a:latin typeface="Arial"/>
               </a:rPr>
-              <a:t>3 / 7</a:t>
+              <a:t>3 / 8</a:t>
             </a:r>
           </a:p>
         </p:txBody>
@@ -5969,7 +5935,7 @@
                 </a:solidFill>
                 <a:latin typeface="Arial"/>
               </a:rPr>
-              <a:t>Extração via LLM dos atributos do Quadro 37 (8 categorias) a partir de documentos .docx não-estruturados.</a:t>
+              <a:t>Extração via LLM dos atributos do Quadro 37 a partir de documentos .docx.</a:t>
             </a:r>
           </a:p>
         </p:txBody>
@@ -6162,7 +6128,7 @@
                 </a:solidFill>
                 <a:latin typeface="Arial"/>
               </a:rPr>
-              <a:t>Dashboard de portfólio com indicador de cobertura do MPO. Visão restrita por perfil: consultoria vê todos, cliente vê apenas o seu.</a:t>
+              <a:t>Dashboard com cobertura do MPO. Cliente vê apenas o seu projeto.</a:t>
             </a:r>
           </a:p>
         </p:txBody>
@@ -6355,7 +6321,7 @@
                 </a:solidFill>
                 <a:latin typeface="Arial"/>
               </a:rPr>
-              <a:t>Autenticação simples + perfis semi-abertos + comentários por projeto + feed in-app de novidades. Materializa Interatividade do MPO.</a:t>
+              <a:t>Auth, perfis semi-abertos, comentários e feed in-app.</a:t>
             </a:r>
           </a:p>
         </p:txBody>
@@ -6548,7 +6514,7 @@
                 </a:solidFill>
                 <a:latin typeface="Arial"/>
               </a:rPr>
-              <a:t>Resumo do projeto para o cliente (IA-tradutora) + drafts de Próximos Passos para o consultor revisar (IA-redutora de fricção).</a:t>
+              <a:t>Resumo do projeto (tradutora) + drafts assistidos (redutora de fricção).</a:t>
             </a:r>
           </a:p>
         </p:txBody>
@@ -6741,7 +6707,7 @@
                 </a:solidFill>
                 <a:latin typeface="Arial"/>
               </a:rPr>
-              <a:t>Quantitativa: precisão, recall, F1 e Kappa em 3 projetos com gabarito manual. Qualitativa: Likert separado para consultoria e clientes.</a:t>
+              <a:t>Precisão · recall · F1 · Kappa em 3 projetos + Likert × 2 audiências.</a:t>
             </a:r>
           </a:p>
         </p:txBody>
@@ -6905,7 +6871,7 @@
                 </a:solidFill>
                 <a:latin typeface="Arial"/>
               </a:rPr>
-              <a:t>Equipe ObiOne · Doutorado PPGEC · UPE/POLI · Maio 2026</a:t>
+              <a:t>Equipe ObiOne · UPE/POLI · Maio 2026</a:t>
             </a:r>
           </a:p>
         </p:txBody>
@@ -6940,7 +6906,7 @@
                 </a:solidFill>
                 <a:latin typeface="Arial"/>
               </a:rPr>
-              <a:t>4 / 7</a:t>
+              <a:t>5 / 8</a:t>
             </a:r>
           </a:p>
         </p:txBody>
@@ -7374,7 +7340,7 @@
                 </a:solidFill>
                 <a:latin typeface="Arial"/>
               </a:rPr>
-              <a:t>Semana 9</a:t>
+              <a:t>22-28 mai</a:t>
             </a:r>
           </a:p>
         </p:txBody>
@@ -7584,7 +7550,7 @@
                 </a:solidFill>
                 <a:latin typeface="Arial"/>
               </a:rPr>
-              <a:t>Destrava todo o Sprint 1 e SR2.</a:t>
+              <a:t>Destrava todo o Sprint 1.</a:t>
             </a:r>
           </a:p>
         </p:txBody>
@@ -7925,7 +7891,7 @@
                 </a:solidFill>
                 <a:latin typeface="Arial"/>
               </a:rPr>
-              <a:t>Semanas 10-11</a:t>
+              <a:t>29 mai - 11 jun</a:t>
             </a:r>
           </a:p>
         </p:txBody>
@@ -8100,7 +8066,7 @@
                 </a:solidFill>
                 <a:latin typeface="Arial"/>
               </a:rPr>
-              <a:t>Núcleo técnico da extração de atributos do MPO.</a:t>
+              <a:t>Núcleo técnico da extração de atributos.</a:t>
             </a:r>
           </a:p>
         </p:txBody>
@@ -8441,7 +8407,7 @@
                 </a:solidFill>
                 <a:latin typeface="Arial"/>
               </a:rPr>
-              <a:t>Semanas 12-13</a:t>
+              <a:t>12-25 jun</a:t>
             </a:r>
           </a:p>
         </p:txBody>
@@ -8651,7 +8617,7 @@
                 </a:solidFill>
                 <a:latin typeface="Arial"/>
               </a:rPr>
-              <a:t>Onde a comunidade do observatório vive.</a:t>
+              <a:t>Onde a comunidade vive.</a:t>
             </a:r>
           </a:p>
         </p:txBody>
@@ -8992,7 +8958,7 @@
                 </a:solidFill>
                 <a:latin typeface="Arial"/>
               </a:rPr>
-              <a:t>Semana 14</a:t>
+              <a:t>26 jun - 2 jul</a:t>
             </a:r>
           </a:p>
         </p:txBody>
@@ -9202,7 +9168,7 @@
                 </a:solidFill>
                 <a:latin typeface="Arial"/>
               </a:rPr>
-              <a:t>Fecha o ciclo DSR (Hevner et al., 2004).</a:t>
+              <a:t>Fecha o ciclo DSR.</a:t>
             </a:r>
           </a:p>
         </p:txBody>
@@ -9315,7 +9281,7 @@
                 </a:solidFill>
                 <a:latin typeface="Arial"/>
               </a:rPr>
-              <a:t>Relato + Apresentação final</a:t>
+              <a:t>Relato + Apresentação</a:t>
             </a:r>
           </a:p>
         </p:txBody>
@@ -9350,200 +9316,7 @@
                 </a:solidFill>
                 <a:latin typeface="Arial"/>
               </a:rPr>
-              <a:t>Escrita do relato: semanas 15-16 (Cynthia) · Apresentação final: 10/07 (Moisés)</a:t>
-            </a:r>
-          </a:p>
-        </p:txBody>
-      </p:sp>
-      <p:sp>
-        <p:nvSpPr>
-          <p:cNvPr id="117" name="Rectangle 116"/>
-          <p:cNvSpPr/>
-          <p:nvPr/>
-        </p:nvSpPr>
-        <p:spPr>
-          <a:xfrm>
-            <a:off x="7000000" y="5577840"/>
-            <a:ext cx="4963600" cy="777240"/>
-          </a:xfrm>
-          <a:prstGeom prst="rect">
-            <a:avLst/>
-          </a:prstGeom>
-          <a:solidFill>
-            <a:srgbClr val="F4F4F6"/>
-          </a:solidFill>
-          <a:ln w="19050">
-            <a:solidFill>
-              <a:srgbClr val="E69A29"/>
-            </a:solidFill>
-          </a:ln>
-        </p:spPr>
-        <p:style>
-          <a:lnRef idx="1">
-            <a:schemeClr val="accent1"/>
-          </a:lnRef>
-          <a:fillRef idx="3">
-            <a:schemeClr val="accent1"/>
-          </a:fillRef>
-          <a:effectRef idx="2">
-            <a:schemeClr val="accent1"/>
-          </a:effectRef>
-          <a:fontRef idx="minor">
-            <a:schemeClr val="lt1"/>
-          </a:fontRef>
-        </p:style>
-        <p:txBody>
-          <a:bodyPr rtlCol="0" anchor="ctr"/>
-          <a:lstStyle/>
-          <a:p>
-            <a:pPr algn="ctr"/>
-          </a:p>
-        </p:txBody>
-      </p:sp>
-      <p:sp>
-        <p:nvSpPr>
-          <p:cNvPr id="118" name="Rectangle 117"/>
-          <p:cNvSpPr/>
-          <p:nvPr/>
-        </p:nvSpPr>
-        <p:spPr>
-          <a:xfrm>
-            <a:off x="7000000" y="5577840"/>
-            <a:ext cx="91440" cy="777240"/>
-          </a:xfrm>
-          <a:prstGeom prst="rect">
-            <a:avLst/>
-          </a:prstGeom>
-          <a:solidFill>
-            <a:srgbClr val="E69A29"/>
-          </a:solidFill>
-          <a:ln>
-            <a:noFill/>
-          </a:ln>
-        </p:spPr>
-        <p:style>
-          <a:lnRef idx="1">
-            <a:schemeClr val="accent1"/>
-          </a:lnRef>
-          <a:fillRef idx="3">
-            <a:schemeClr val="accent1"/>
-          </a:fillRef>
-          <a:effectRef idx="2">
-            <a:schemeClr val="accent1"/>
-          </a:effectRef>
-          <a:fontRef idx="minor">
-            <a:schemeClr val="lt1"/>
-          </a:fontRef>
-        </p:style>
-        <p:txBody>
-          <a:bodyPr rtlCol="0" anchor="ctr"/>
-          <a:lstStyle/>
-          <a:p>
-            <a:pPr algn="ctr"/>
-          </a:p>
-        </p:txBody>
-      </p:sp>
-      <p:sp>
-        <p:nvSpPr>
-          <p:cNvPr id="119" name="TextBox 118"/>
-          <p:cNvSpPr txBox="1"/>
-          <p:nvPr/>
-        </p:nvSpPr>
-        <p:spPr>
-          <a:xfrm>
-            <a:off x="7200000" y="5623560"/>
-            <a:ext cx="4700000" cy="228600"/>
-          </a:xfrm>
-          <a:prstGeom prst="rect">
-            <a:avLst/>
-          </a:prstGeom>
-          <a:noFill/>
-        </p:spPr>
-        <p:txBody>
-          <a:bodyPr wrap="square" lIns="0" rIns="0" tIns="0" bIns="0" anchor="t">
-            <a:spAutoFit/>
-          </a:bodyPr>
-          <a:lstStyle/>
-          <a:p>
-            <a:pPr algn="l"/>
-            <a:r>
-              <a:rPr sz="900" b="1" i="0">
-                <a:solidFill>
-                  <a:srgbClr val="C8102E"/>
-                </a:solidFill>
-                <a:latin typeface="Arial"/>
-              </a:rPr>
-              <a:t>PLANO B (LIKERT)</a:t>
-            </a:r>
-          </a:p>
-        </p:txBody>
-      </p:sp>
-      <p:sp>
-        <p:nvSpPr>
-          <p:cNvPr id="120" name="TextBox 119"/>
-          <p:cNvSpPr txBox="1"/>
-          <p:nvPr/>
-        </p:nvSpPr>
-        <p:spPr>
-          <a:xfrm>
-            <a:off x="7200000" y="5852160"/>
-            <a:ext cx="4700000" cy="228600"/>
-          </a:xfrm>
-          <a:prstGeom prst="rect">
-            <a:avLst/>
-          </a:prstGeom>
-          <a:noFill/>
-        </p:spPr>
-        <p:txBody>
-          <a:bodyPr wrap="square" lIns="0" rIns="0" tIns="0" bIns="0" anchor="t">
-            <a:spAutoFit/>
-          </a:bodyPr>
-          <a:lstStyle/>
-          <a:p>
-            <a:pPr algn="l"/>
-            <a:r>
-              <a:rPr sz="1100" b="1" i="0">
-                <a:solidFill>
-                  <a:srgbClr val="C8102E"/>
-                </a:solidFill>
-                <a:latin typeface="Arial"/>
-              </a:rPr>
-              <a:t>Se Likert dos clientes não atingir N ≥ 8:</a:t>
-            </a:r>
-          </a:p>
-        </p:txBody>
-      </p:sp>
-      <p:sp>
-        <p:nvSpPr>
-          <p:cNvPr id="121" name="TextBox 120"/>
-          <p:cNvSpPr txBox="1"/>
-          <p:nvPr/>
-        </p:nvSpPr>
-        <p:spPr>
-          <a:xfrm>
-            <a:off x="7200000" y="6080760"/>
-            <a:ext cx="4700000" cy="304800"/>
-          </a:xfrm>
-          <a:prstGeom prst="rect">
-            <a:avLst/>
-          </a:prstGeom>
-          <a:noFill/>
-        </p:spPr>
-        <p:txBody>
-          <a:bodyPr wrap="square" lIns="0" rIns="0" tIns="0" bIns="0" anchor="t">
-            <a:spAutoFit/>
-          </a:bodyPr>
-          <a:lstStyle/>
-          <a:p>
-            <a:pPr algn="l"/>
-            <a:r>
-              <a:rPr sz="1000" b="0" i="0">
-                <a:solidFill>
-                  <a:srgbClr val="4A4A5A"/>
-                </a:solidFill>
-                <a:latin typeface="Arial"/>
-              </a:rPr>
-              <a:t>Aceitar 1 respondente por projeto e declarar como limitação metodológica no relato.</a:t>
+              <a:t>Escrita do relato: 3-9 jul · Apresentação final: 10/07</a:t>
             </a:r>
           </a:p>
         </p:txBody>
@@ -9664,7 +9437,7 @@
                 </a:solidFill>
                 <a:latin typeface="Arial"/>
               </a:rPr>
-              <a:t>Equipe ObiOne · Doutorado PPGEC · UPE/POLI · Maio 2026</a:t>
+              <a:t>Equipe ObiOne · UPE/POLI · Maio 2026</a:t>
             </a:r>
           </a:p>
         </p:txBody>
@@ -9699,7 +9472,7 @@
                 </a:solidFill>
                 <a:latin typeface="Arial"/>
               </a:rPr>
-              <a:t>5 / 7</a:t>
+              <a:t>6 / 8</a:t>
             </a:r>
           </a:p>
         </p:txBody>
@@ -10020,7 +9793,7 @@
                 </a:solidFill>
                 <a:latin typeface="Arial"/>
               </a:rPr>
-              <a:t>Sprint 0 · esta semana</a:t>
+              <a:t>Sprint 1 · esta semana</a:t>
             </a:r>
           </a:p>
         </p:txBody>
@@ -10125,7 +9898,7 @@
                 </a:solidFill>
                 <a:latin typeface="Arial"/>
               </a:rPr>
-              <a:t>18 funcionais + 9 não funcionais em formato ficha simplificada.</a:t>
+              <a:t>18 funcionais + 9 não funcionais em formato ficha.</a:t>
             </a:r>
           </a:p>
         </p:txBody>
@@ -10230,7 +10003,7 @@
                 </a:solidFill>
                 <a:latin typeface="Arial"/>
               </a:rPr>
-              <a:t>44 atributos do Quadro 37 categorizados como estruturado, texto livre ou fora de escopo.</a:t>
+              <a:t>44 atributos do Quadro 37 categorizados.</a:t>
             </a:r>
           </a:p>
         </p:txBody>
@@ -10335,7 +10108,7 @@
                 </a:solidFill>
                 <a:latin typeface="Arial"/>
               </a:rPr>
-              <a:t>Rubrica híbrida 0/0,5/1 + Kappa para concordância entre avaliadores.</a:t>
+              <a:t>Rubrica híbrida 0/0,5/1 + Kappa.</a:t>
             </a:r>
           </a:p>
         </p:txBody>
@@ -10563,7 +10336,7 @@
                 </a:solidFill>
                 <a:latin typeface="Arial"/>
               </a:rPr>
-              <a:t>Sprint 1 (sem 9-10)</a:t>
+              <a:t>Sprint 2 (22 mai - 4 jun)</a:t>
             </a:r>
           </a:p>
         </p:txBody>
@@ -10598,7 +10371,7 @@
                 </a:solidFill>
                 <a:latin typeface="Arial"/>
               </a:rPr>
-              <a:t>Cadastro · upload · autenticação · pipeline LLM rodando nos 5 projetos.</a:t>
+              <a:t>Cadastro · upload · auth · pipeline LLM nos 5 projetos.</a:t>
             </a:r>
           </a:p>
         </p:txBody>
@@ -10703,7 +10476,7 @@
                 </a:solidFill>
                 <a:latin typeface="Arial"/>
               </a:rPr>
-              <a:t>Valença Odontologia como piloto da rubrica · depois Freire Batista e Kaka JJ.</a:t>
+              <a:t>Valença piloto · depois Freire Batista e Kaka JJ.</a:t>
             </a:r>
           </a:p>
         </p:txBody>
@@ -10808,7 +10581,7 @@
                 </a:solidFill>
                 <a:latin typeface="Arial"/>
               </a:rPr>
-              <a:t>Dashboard + IA-Assistente operacionais nos 5 projetos.</a:t>
+              <a:t>Dashboard + IA-Assistente operacionais.</a:t>
             </a:r>
           </a:p>
         </p:txBody>
@@ -10972,7 +10745,7 @@
                 </a:solidFill>
                 <a:latin typeface="Arial"/>
               </a:rPr>
-              <a:t>Equipe ObiOne · Doutorado PPGEC · UPE/POLI · Maio 2026</a:t>
+              <a:t>Equipe ObiOne · UPE/POLI · Maio 2026</a:t>
             </a:r>
           </a:p>
         </p:txBody>
@@ -11007,7 +10780,7 @@
                 </a:solidFill>
                 <a:latin typeface="Arial"/>
               </a:rPr>
-              <a:t>6 / 7</a:t>
+              <a:t>7 / 8</a:t>
             </a:r>
           </a:p>
         </p:txBody>
@@ -11318,7 +11091,7 @@
                 </a:solidFill>
                 <a:latin typeface="Arial"/>
               </a:rPr>
-              <a:t>Bruno · Cynthia · Moisés · Raniel  ·  Doutorado PPGEC  ·  UPE/POLI</a:t>
+              <a:t>Equipe ObiOne  ·  UPE/POLI</a:t>
             </a:r>
           </a:p>
         </p:txBody>
@@ -11358,6 +11131,1101 @@
           </a:p>
         </p:txBody>
       </p:sp>
+    </p:spTree>
+  </p:cSld>
+  <p:clrMapOvr>
+    <a:masterClrMapping/>
+  </p:clrMapOvr>
+</p:sld>
+</file>
+
+<file path=ppt/slides/slide8.xml><?xml version="1.0" encoding="utf-8"?>
+<p:sld xmlns:a="http://schemas.openxmlformats.org/drawingml/2006/main" xmlns:p="http://schemas.openxmlformats.org/presentationml/2006/main" xmlns:r="http://schemas.openxmlformats.org/officeDocument/2006/relationships">
+  <p:cSld>
+    <p:spTree>
+      <p:nvGrpSpPr>
+        <p:cNvPr id="1" name=""/>
+        <p:cNvGrpSpPr/>
+        <p:nvPr/>
+      </p:nvGrpSpPr>
+      <p:grpSpPr/>
+      <p:sp>
+        <p:nvSpPr>
+          <p:cNvPr id="3" name="TextBox 2"/>
+          <p:cNvSpPr txBox="1"/>
+          <p:nvPr/>
+        </p:nvSpPr>
+        <p:spPr>
+          <a:xfrm>
+            <a:off x="457200" y="457200"/>
+            <a:ext cx="11277600" cy="228600"/>
+          </a:xfrm>
+          <a:prstGeom prst="rect">
+            <a:avLst/>
+          </a:prstGeom>
+          <a:noFill/>
+        </p:spPr>
+        <p:txBody>
+          <a:bodyPr wrap="square" lIns="0" rIns="0" tIns="0" bIns="0" anchor="t">
+            <a:spAutoFit/>
+          </a:bodyPr>
+          <a:lstStyle/>
+          <a:p>
+            <a:pPr algn="l"/>
+            <a:r>
+              <a:rPr sz="1100" b="1" i="0">
+                <a:solidFill>
+                  <a:srgbClr val="E0261E"/>
+                </a:solidFill>
+                <a:latin typeface="Arial"/>
+              </a:rPr>
+              <a:t>O QUE É O OBIONE</a:t>
+            </a:r>
+          </a:p>
+        </p:txBody>
+      </p:sp>
+      <p:sp>
+        <p:nvSpPr>
+          <p:cNvPr id="4" name="TextBox 3"/>
+          <p:cNvSpPr txBox="1"/>
+          <p:nvPr/>
+        </p:nvSpPr>
+        <p:spPr>
+          <a:xfrm>
+            <a:off x="457200" y="685800"/>
+            <a:ext cx="10000000" cy="685800"/>
+          </a:xfrm>
+          <a:prstGeom prst="rect">
+            <a:avLst/>
+          </a:prstGeom>
+          <a:noFill/>
+        </p:spPr>
+        <p:txBody>
+          <a:bodyPr wrap="square" lIns="0" rIns="0" tIns="0" bIns="0" anchor="t">
+            <a:spAutoFit/>
+          </a:bodyPr>
+          <a:lstStyle/>
+          <a:p>
+            <a:pPr algn="l"/>
+            <a:r>
+              <a:rPr sz="2800" b="1" i="0">
+                <a:solidFill>
+                  <a:srgbClr val="1F3A6B"/>
+                </a:solidFill>
+                <a:latin typeface="Arial"/>
+              </a:rPr>
+              <a:t>Observatório-de-portfólio para consultoria de projetos</a:t>
+            </a:r>
+          </a:p>
+        </p:txBody>
+      </p:sp>
+      <p:sp>
+        <p:nvSpPr>
+          <p:cNvPr id="5" name="Rectangle 4"/>
+          <p:cNvSpPr/>
+          <p:nvPr/>
+        </p:nvSpPr>
+        <p:spPr>
+          <a:xfrm>
+            <a:off x="457200" y="1432560"/>
+            <a:ext cx="685800" cy="36576"/>
+          </a:xfrm>
+          <a:prstGeom prst="rect">
+            <a:avLst/>
+          </a:prstGeom>
+          <a:solidFill>
+            <a:srgbClr val="E0261E"/>
+          </a:solidFill>
+          <a:ln>
+            <a:noFill/>
+          </a:ln>
+        </p:spPr>
+        <p:style>
+          <a:lnRef idx="1">
+            <a:schemeClr val="accent1"/>
+          </a:lnRef>
+          <a:fillRef idx="3">
+            <a:schemeClr val="accent1"/>
+          </a:fillRef>
+          <a:effectRef idx="2">
+            <a:schemeClr val="accent1"/>
+          </a:effectRef>
+          <a:fontRef idx="minor">
+            <a:schemeClr val="lt1"/>
+          </a:fontRef>
+        </p:style>
+        <p:txBody>
+          <a:bodyPr rtlCol="0" anchor="ctr"/>
+          <a:lstStyle/>
+          <a:p>
+            <a:pPr algn="ctr"/>
+          </a:p>
+        </p:txBody>
+      </p:sp>
+      <p:sp>
+        <p:nvSpPr>
+          <p:cNvPr id="6" name="Rectangle 5"/>
+          <p:cNvSpPr/>
+          <p:nvPr/>
+        </p:nvSpPr>
+        <p:spPr>
+          <a:xfrm>
+            <a:off x="685800" y="1828800"/>
+            <a:ext cx="5486400" cy="4114800"/>
+          </a:xfrm>
+          <a:prstGeom prst="rect">
+            <a:avLst/>
+          </a:prstGeom>
+          <a:solidFill>
+            <a:srgbClr val="F4F4F6"/>
+          </a:solidFill>
+          <a:ln w="9525">
+            <a:solidFill>
+              <a:srgbClr val="D4D4DC"/>
+            </a:solidFill>
+          </a:ln>
+        </p:spPr>
+        <p:style>
+          <a:lnRef idx="1">
+            <a:schemeClr val="accent1"/>
+          </a:lnRef>
+          <a:fillRef idx="3">
+            <a:schemeClr val="accent1"/>
+          </a:fillRef>
+          <a:effectRef idx="2">
+            <a:schemeClr val="accent1"/>
+          </a:effectRef>
+          <a:fontRef idx="minor">
+            <a:schemeClr val="lt1"/>
+          </a:fontRef>
+        </p:style>
+        <p:txBody>
+          <a:bodyPr rtlCol="0" anchor="ctr"/>
+          <a:lstStyle/>
+          <a:p>
+            <a:pPr algn="ctr"/>
+          </a:p>
+        </p:txBody>
+      </p:sp>
+      <p:sp>
+        <p:nvSpPr>
+          <p:cNvPr id="7" name="TextBox 6"/>
+          <p:cNvSpPr txBox="1"/>
+          <p:nvPr/>
+        </p:nvSpPr>
+        <p:spPr>
+          <a:xfrm>
+            <a:off x="914400" y="2057400"/>
+            <a:ext cx="5029200" cy="304800"/>
+          </a:xfrm>
+          <a:prstGeom prst="rect">
+            <a:avLst/>
+          </a:prstGeom>
+          <a:noFill/>
+        </p:spPr>
+        <p:txBody>
+          <a:bodyPr wrap="square" lIns="0" rIns="0" tIns="0" bIns="0" anchor="t">
+            <a:spAutoFit/>
+          </a:bodyPr>
+          <a:lstStyle/>
+          <a:p>
+            <a:pPr algn="l"/>
+            <a:r>
+              <a:rPr sz="1100" b="1" i="0">
+                <a:solidFill>
+                  <a:srgbClr val="E0261E"/>
+                </a:solidFill>
+                <a:latin typeface="Arial"/>
+              </a:rPr>
+              <a:t>PARA QUEM E PARA QUÊ</a:t>
+            </a:r>
+          </a:p>
+        </p:txBody>
+      </p:sp>
+      <p:sp>
+        <p:nvSpPr>
+          <p:cNvPr id="8" name="TextBox 7"/>
+          <p:cNvSpPr txBox="1"/>
+          <p:nvPr/>
+        </p:nvSpPr>
+        <p:spPr>
+          <a:xfrm>
+            <a:off x="914400" y="2377440"/>
+            <a:ext cx="5029200" cy="457200"/>
+          </a:xfrm>
+          <a:prstGeom prst="rect">
+            <a:avLst/>
+          </a:prstGeom>
+          <a:noFill/>
+        </p:spPr>
+        <p:txBody>
+          <a:bodyPr wrap="square" lIns="0" rIns="0" tIns="0" bIns="0" anchor="t">
+            <a:spAutoFit/>
+          </a:bodyPr>
+          <a:lstStyle/>
+          <a:p>
+            <a:pPr algn="l"/>
+            <a:r>
+              <a:rPr sz="2200" b="1" i="0">
+                <a:solidFill>
+                  <a:srgbClr val="1F3A6B"/>
+                </a:solidFill>
+                <a:latin typeface="Arial"/>
+              </a:rPr>
+              <a:t>Consultoria · Clientes · Comunidade</a:t>
+            </a:r>
+          </a:p>
+          <a:p>
+            <a:pPr algn="l"/>
+            <a:r>
+              <a:rPr sz="800" b="0" i="0">
+                <a:solidFill>
+                  <a:srgbClr val="2C2C3E"/>
+                </a:solidFill>
+                <a:latin typeface="Arial"/>
+              </a:rPr>
+              <a:t/>
+            </a:r>
+          </a:p>
+          <a:p>
+            <a:pPr algn="l">
+              <a:spcAft>
+                <a:spcPts val="800"/>
+              </a:spcAft>
+            </a:pPr>
+            <a:r>
+              <a:rPr sz="1300" b="0" i="0">
+                <a:solidFill>
+                  <a:srgbClr val="2C2C3E"/>
+                </a:solidFill>
+                <a:latin typeface="Arial"/>
+              </a:rPr>
+              <a:t>Consultoria: observa o portfólio como conhecimento estruturado, não como pasta de Drive.</a:t>
+            </a:r>
+          </a:p>
+          <a:p>
+            <a:pPr algn="l">
+              <a:spcAft>
+                <a:spcPts val="800"/>
+              </a:spcAft>
+            </a:pPr>
+            <a:r>
+              <a:rPr sz="1300" b="0" i="0">
+                <a:solidFill>
+                  <a:srgbClr val="2C2C3E"/>
+                </a:solidFill>
+                <a:latin typeface="Arial"/>
+              </a:rPr>
+              <a:t>Cliente: acompanha o próprio projeto em linguagem acessível, sem depender de reunião.</a:t>
+            </a:r>
+          </a:p>
+          <a:p>
+            <a:pPr algn="l"/>
+            <a:r>
+              <a:rPr sz="1300" b="0" i="1">
+                <a:solidFill>
+                  <a:srgbClr val="2C2C3E"/>
+                </a:solidFill>
+                <a:latin typeface="Arial"/>
+              </a:rPr>
+              <a:t>Comunidade vira ativo: comentários, comparativos cross-projeto, IA mantém o tecido vivo.</a:t>
+            </a:r>
+          </a:p>
+        </p:txBody>
+      </p:sp>
+      <p:sp>
+        <p:nvSpPr>
+          <p:cNvPr id="13" name="Rectangle 12"/>
+          <p:cNvSpPr/>
+          <p:nvPr/>
+        </p:nvSpPr>
+        <p:spPr>
+          <a:xfrm>
+            <a:off x="457200" y="6400800"/>
+            <a:ext cx="11277600" cy="15240"/>
+          </a:xfrm>
+          <a:prstGeom prst="rect">
+            <a:avLst/>
+          </a:prstGeom>
+          <a:solidFill>
+            <a:srgbClr val="E0261E"/>
+          </a:solidFill>
+          <a:ln>
+            <a:noFill/>
+          </a:ln>
+        </p:spPr>
+        <p:style>
+          <a:lnRef idx="1">
+            <a:schemeClr val="accent1"/>
+          </a:lnRef>
+          <a:fillRef idx="3">
+            <a:schemeClr val="accent1"/>
+          </a:fillRef>
+          <a:effectRef idx="2">
+            <a:schemeClr val="accent1"/>
+          </a:effectRef>
+          <a:fontRef idx="minor">
+            <a:schemeClr val="lt1"/>
+          </a:fontRef>
+        </p:style>
+        <p:txBody>
+          <a:bodyPr rtlCol="0" anchor="ctr"/>
+          <a:lstStyle/>
+          <a:p>
+            <a:pPr algn="ctr"/>
+          </a:p>
+        </p:txBody>
+      </p:sp>
+      <p:sp>
+        <p:nvSpPr>
+          <p:cNvPr id="16" name="Rectangle 15"/>
+          <p:cNvSpPr/>
+          <p:nvPr/>
+        </p:nvSpPr>
+        <p:spPr>
+          <a:xfrm>
+            <a:off x="6400800" y="1828800"/>
+            <a:ext cx="5486400" cy="4114800"/>
+          </a:xfrm>
+          <a:prstGeom prst="rect">
+            <a:avLst/>
+          </a:prstGeom>
+          <a:solidFill>
+            <a:srgbClr val="F4F4F6"/>
+          </a:solidFill>
+          <a:ln w="9525">
+            <a:solidFill>
+              <a:srgbClr val="D4D4DC"/>
+            </a:solidFill>
+          </a:ln>
+        </p:spPr>
+        <p:style>
+          <a:lnRef idx="1">
+            <a:schemeClr val="accent1"/>
+          </a:lnRef>
+          <a:fillRef idx="3">
+            <a:schemeClr val="accent1"/>
+          </a:fillRef>
+          <a:effectRef idx="2">
+            <a:schemeClr val="accent1"/>
+          </a:effectRef>
+          <a:fontRef idx="minor">
+            <a:schemeClr val="lt1"/>
+          </a:fontRef>
+        </p:style>
+        <p:txBody>
+          <a:bodyPr rtlCol="0" anchor="ctr"/>
+          <a:lstStyle/>
+          <a:p>
+            <a:pPr algn="ctr"/>
+          </a:p>
+        </p:txBody>
+      </p:sp>
+      <p:sp>
+        <p:nvSpPr>
+          <p:cNvPr id="17" name="TextBox 16"/>
+          <p:cNvSpPr txBox="1"/>
+          <p:nvPr/>
+        </p:nvSpPr>
+        <p:spPr>
+          <a:xfrm>
+            <a:off x="6629400" y="2057400"/>
+            <a:ext cx="5029200" cy="304800"/>
+          </a:xfrm>
+          <a:prstGeom prst="rect">
+            <a:avLst/>
+          </a:prstGeom>
+          <a:noFill/>
+        </p:spPr>
+        <p:txBody>
+          <a:bodyPr wrap="square" lIns="0" rIns="0" tIns="0" bIns="0" anchor="t">
+            <a:spAutoFit/>
+          </a:bodyPr>
+          <a:lstStyle/>
+          <a:p>
+            <a:pPr algn="l"/>
+            <a:r>
+              <a:rPr sz="1100" b="1" i="0">
+                <a:solidFill>
+                  <a:srgbClr val="E0261E"/>
+                </a:solidFill>
+                <a:latin typeface="Arial"/>
+              </a:rPr>
+              <a:t>DIFERENCIAL</a:t>
+            </a:r>
+          </a:p>
+        </p:txBody>
+      </p:sp>
+      <p:sp>
+        <p:nvSpPr>
+          <p:cNvPr id="18" name="TextBox 17"/>
+          <p:cNvSpPr txBox="1"/>
+          <p:nvPr/>
+        </p:nvSpPr>
+        <p:spPr>
+          <a:xfrm>
+            <a:off x="6629400" y="2377440"/>
+            <a:ext cx="5029200" cy="457200"/>
+          </a:xfrm>
+          <a:prstGeom prst="rect">
+            <a:avLst/>
+          </a:prstGeom>
+          <a:noFill/>
+        </p:spPr>
+        <p:txBody>
+          <a:bodyPr wrap="square" lIns="0" rIns="0" tIns="0" bIns="0" anchor="t">
+            <a:spAutoFit/>
+          </a:bodyPr>
+          <a:lstStyle/>
+          <a:p>
+            <a:pPr algn="l"/>
+            <a:r>
+              <a:rPr sz="2200" b="1" i="0">
+                <a:solidFill>
+                  <a:srgbClr val="1F3A6B"/>
+                </a:solidFill>
+                <a:latin typeface="Arial"/>
+              </a:rPr>
+              <a:t>Combinação inédita em 3 vetores</a:t>
+            </a:r>
+          </a:p>
+        </p:txBody>
+      </p:sp>
+      <p:sp>
+        <p:nvSpPr>
+          <p:cNvPr id="19" name="TextBox 18"/>
+          <p:cNvSpPr txBox="1"/>
+          <p:nvPr/>
+        </p:nvSpPr>
+        <p:spPr>
+          <a:xfrm>
+            <a:off x="6629400" y="3017520"/>
+            <a:ext cx="1500000" cy="365760"/>
+          </a:xfrm>
+          <a:prstGeom prst="rect">
+            <a:avLst/>
+          </a:prstGeom>
+          <a:noFill/>
+        </p:spPr>
+        <p:txBody>
+          <a:bodyPr wrap="square" lIns="0" rIns="0" tIns="0" bIns="0" anchor="t">
+            <a:spAutoFit/>
+          </a:bodyPr>
+          <a:lstStyle/>
+          <a:p>
+            <a:pPr algn="l"/>
+            <a:r>
+              <a:rPr sz="2200" b="1" i="0">
+                <a:solidFill>
+                  <a:srgbClr val="E0261E"/>
+                </a:solidFill>
+                <a:latin typeface="Arial"/>
+              </a:rPr>
+              <a:t>vs. PM</a:t>
+            </a:r>
+          </a:p>
+        </p:txBody>
+      </p:sp>
+      <p:sp>
+        <p:nvSpPr>
+          <p:cNvPr id="20" name="TextBox 19"/>
+          <p:cNvSpPr txBox="1"/>
+          <p:nvPr/>
+        </p:nvSpPr>
+        <p:spPr>
+          <a:xfrm>
+            <a:off x="8200000" y="3048000"/>
+            <a:ext cx="3500000" cy="304800"/>
+          </a:xfrm>
+          <a:prstGeom prst="rect">
+            <a:avLst/>
+          </a:prstGeom>
+          <a:noFill/>
+        </p:spPr>
+        <p:txBody>
+          <a:bodyPr wrap="square" lIns="0" rIns="0" tIns="0" bIns="0" anchor="t">
+            <a:spAutoFit/>
+          </a:bodyPr>
+          <a:lstStyle/>
+          <a:p>
+            <a:pPr algn="l"/>
+            <a:r>
+              <a:rPr sz="1200" b="1" i="0">
+                <a:solidFill>
+                  <a:srgbClr val="1F3A6B"/>
+                </a:solidFill>
+                <a:latin typeface="Arial"/>
+              </a:rPr>
+              <a:t>Jira, Trello: gerenciam tarefas e prazos</a:t>
+            </a:r>
+          </a:p>
+        </p:txBody>
+      </p:sp>
+      <p:sp>
+        <p:nvSpPr>
+          <p:cNvPr id="21" name="TextBox 20"/>
+          <p:cNvSpPr txBox="1"/>
+          <p:nvPr/>
+        </p:nvSpPr>
+        <p:spPr>
+          <a:xfrm>
+            <a:off x="8200000" y="3291840"/>
+            <a:ext cx="3500000" cy="228600"/>
+          </a:xfrm>
+          <a:prstGeom prst="rect">
+            <a:avLst/>
+          </a:prstGeom>
+          <a:noFill/>
+        </p:spPr>
+        <p:txBody>
+          <a:bodyPr wrap="square" lIns="0" rIns="0" tIns="0" bIns="0" anchor="t">
+            <a:spAutoFit/>
+          </a:bodyPr>
+          <a:lstStyle/>
+          <a:p>
+            <a:pPr algn="l"/>
+            <a:r>
+              <a:rPr sz="1000" b="0" i="0">
+                <a:solidFill>
+                  <a:srgbClr val="4A4A5A"/>
+                </a:solidFill>
+                <a:latin typeface="Arial"/>
+              </a:rPr>
+              <a:t>ObiOne observa o projeto como objeto (MPO · 44 atributos)</a:t>
+            </a:r>
+          </a:p>
+        </p:txBody>
+      </p:sp>
+      <p:sp>
+        <p:nvSpPr>
+          <p:cNvPr id="22" name="TextBox 21"/>
+          <p:cNvSpPr txBox="1"/>
+          <p:nvPr/>
+        </p:nvSpPr>
+        <p:spPr>
+          <a:xfrm>
+            <a:off x="6629400" y="3703320"/>
+            <a:ext cx="1500000" cy="365760"/>
+          </a:xfrm>
+          <a:prstGeom prst="rect">
+            <a:avLst/>
+          </a:prstGeom>
+          <a:noFill/>
+        </p:spPr>
+        <p:txBody>
+          <a:bodyPr wrap="square" lIns="0" rIns="0" tIns="0" bIns="0" anchor="t">
+            <a:spAutoFit/>
+          </a:bodyPr>
+          <a:lstStyle/>
+          <a:p>
+            <a:pPr algn="l"/>
+            <a:r>
+              <a:rPr sz="2200" b="1" i="0">
+                <a:solidFill>
+                  <a:srgbClr val="E0261E"/>
+                </a:solidFill>
+                <a:latin typeface="Arial"/>
+              </a:rPr>
+              <a:t>vs. BI</a:t>
+            </a:r>
+          </a:p>
+        </p:txBody>
+      </p:sp>
+      <p:sp>
+        <p:nvSpPr>
+          <p:cNvPr id="23" name="TextBox 22"/>
+          <p:cNvSpPr txBox="1"/>
+          <p:nvPr/>
+        </p:nvSpPr>
+        <p:spPr>
+          <a:xfrm>
+            <a:off x="8200000" y="3733800"/>
+            <a:ext cx="3500000" cy="304800"/>
+          </a:xfrm>
+          <a:prstGeom prst="rect">
+            <a:avLst/>
+          </a:prstGeom>
+          <a:noFill/>
+        </p:spPr>
+        <p:txBody>
+          <a:bodyPr wrap="square" lIns="0" rIns="0" tIns="0" bIns="0" anchor="t">
+            <a:spAutoFit/>
+          </a:bodyPr>
+          <a:lstStyle/>
+          <a:p>
+            <a:pPr algn="l"/>
+            <a:r>
+              <a:rPr sz="1200" b="1" i="0">
+                <a:solidFill>
+                  <a:srgbClr val="1F3A6B"/>
+                </a:solidFill>
+                <a:latin typeface="Arial"/>
+              </a:rPr>
+              <a:t>Power BI, Looker: dashboards estáticos</a:t>
+            </a:r>
+          </a:p>
+        </p:txBody>
+      </p:sp>
+      <p:sp>
+        <p:nvSpPr>
+          <p:cNvPr id="24" name="TextBox 23"/>
+          <p:cNvSpPr txBox="1"/>
+          <p:nvPr/>
+        </p:nvSpPr>
+        <p:spPr>
+          <a:xfrm>
+            <a:off x="8200000" y="3977640"/>
+            <a:ext cx="3500000" cy="228600"/>
+          </a:xfrm>
+          <a:prstGeom prst="rect">
+            <a:avLst/>
+          </a:prstGeom>
+          <a:noFill/>
+        </p:spPr>
+        <p:txBody>
+          <a:bodyPr wrap="square" lIns="0" rIns="0" tIns="0" bIns="0" anchor="t">
+            <a:spAutoFit/>
+          </a:bodyPr>
+          <a:lstStyle/>
+          <a:p>
+            <a:pPr algn="l"/>
+            <a:r>
+              <a:rPr sz="1000" b="0" i="0">
+                <a:solidFill>
+                  <a:srgbClr val="4A4A5A"/>
+                </a:solidFill>
+                <a:latin typeface="Arial"/>
+              </a:rPr>
+              <a:t>ObiOne extrai significado de .docx com LLM</a:t>
+            </a:r>
+          </a:p>
+        </p:txBody>
+      </p:sp>
+      <p:sp>
+        <p:nvSpPr>
+          <p:cNvPr id="25" name="TextBox 24"/>
+          <p:cNvSpPr txBox="1"/>
+          <p:nvPr/>
+        </p:nvSpPr>
+        <p:spPr>
+          <a:xfrm>
+            <a:off x="6629400" y="4389120"/>
+            <a:ext cx="1500000" cy="365760"/>
+          </a:xfrm>
+          <a:prstGeom prst="rect">
+            <a:avLst/>
+          </a:prstGeom>
+          <a:noFill/>
+        </p:spPr>
+        <p:txBody>
+          <a:bodyPr wrap="square" lIns="0" rIns="0" tIns="0" bIns="0" anchor="t">
+            <a:spAutoFit/>
+          </a:bodyPr>
+          <a:lstStyle/>
+          <a:p>
+            <a:pPr algn="l"/>
+            <a:r>
+              <a:rPr sz="2200" b="1" i="0">
+                <a:solidFill>
+                  <a:srgbClr val="E0261E"/>
+                </a:solidFill>
+                <a:latin typeface="Arial"/>
+              </a:rPr>
+              <a:t>vs. acad</a:t>
+            </a:r>
+          </a:p>
+        </p:txBody>
+      </p:sp>
+      <p:sp>
+        <p:nvSpPr>
+          <p:cNvPr id="26" name="TextBox 25"/>
+          <p:cNvSpPr txBox="1"/>
+          <p:nvPr/>
+        </p:nvSpPr>
+        <p:spPr>
+          <a:xfrm>
+            <a:off x="8200000" y="4419600"/>
+            <a:ext cx="3500000" cy="304800"/>
+          </a:xfrm>
+          <a:prstGeom prst="rect">
+            <a:avLst/>
+          </a:prstGeom>
+          <a:noFill/>
+        </p:spPr>
+        <p:txBody>
+          <a:bodyPr wrap="square" lIns="0" rIns="0" tIns="0" bIns="0" anchor="t">
+            <a:spAutoFit/>
+          </a:bodyPr>
+          <a:lstStyle/>
+          <a:p>
+            <a:pPr algn="l"/>
+            <a:r>
+              <a:rPr sz="1200" b="1" i="0">
+                <a:solidFill>
+                  <a:srgbClr val="1F3A6B"/>
+                </a:solidFill>
+                <a:latin typeface="Arial"/>
+              </a:rPr>
+              <a:t>OPTI-PE e similares: instrumentos de pesquisa</a:t>
+            </a:r>
+          </a:p>
+        </p:txBody>
+      </p:sp>
+      <p:sp>
+        <p:nvSpPr>
+          <p:cNvPr id="27" name="TextBox 26"/>
+          <p:cNvSpPr txBox="1"/>
+          <p:nvPr/>
+        </p:nvSpPr>
+        <p:spPr>
+          <a:xfrm>
+            <a:off x="8200000" y="4663440"/>
+            <a:ext cx="3500000" cy="228600"/>
+          </a:xfrm>
+          <a:prstGeom prst="rect">
+            <a:avLst/>
+          </a:prstGeom>
+          <a:noFill/>
+        </p:spPr>
+        <p:txBody>
+          <a:bodyPr wrap="square" lIns="0" rIns="0" tIns="0" bIns="0" anchor="t">
+            <a:spAutoFit/>
+          </a:bodyPr>
+          <a:lstStyle/>
+          <a:p>
+            <a:pPr algn="l"/>
+            <a:r>
+              <a:rPr sz="1000" b="0" i="0">
+                <a:solidFill>
+                  <a:srgbClr val="4A4A5A"/>
+                </a:solidFill>
+                <a:latin typeface="Arial"/>
+              </a:rPr>
+              <a:t>ObiOne é operacional: consultoria + clientes no dia-a-dia</a:t>
+            </a:r>
+          </a:p>
+        </p:txBody>
+      </p:sp>
+      <p:sp>
+        <p:nvSpPr>
+          <p:cNvPr id="28" name="TextBox 27"/>
+          <p:cNvSpPr txBox="1"/>
+          <p:nvPr/>
+        </p:nvSpPr>
+        <p:spPr>
+          <a:xfrm>
+            <a:off x="685800" y="6172200"/>
+            <a:ext cx="11277600" cy="228600"/>
+          </a:xfrm>
+          <a:prstGeom prst="rect">
+            <a:avLst/>
+          </a:prstGeom>
+          <a:noFill/>
+        </p:spPr>
+        <p:txBody>
+          <a:bodyPr wrap="square" lIns="0" rIns="0" tIns="0" bIns="0" anchor="t">
+            <a:spAutoFit/>
+          </a:bodyPr>
+          <a:lstStyle/>
+          <a:p>
+            <a:pPr algn="ctr"/>
+            <a:r>
+              <a:rPr sz="1400" b="1" i="0">
+                <a:solidFill>
+                  <a:srgbClr val="1F3A6B"/>
+                </a:solidFill>
+                <a:latin typeface="Arial"/>
+              </a:rPr>
+              <a:t>Único a combinar observação MPO + extração com IA + comunidade ativa em uma só plataforma.</a:t>
+            </a:r>
+          </a:p>
+        </p:txBody>
+      </p:sp>
+      <p:sp>
+        <p:nvSpPr>
+          <p:cNvPr id="29" name="Rectangle 28"/>
+          <p:cNvSpPr/>
+          <p:nvPr/>
+        </p:nvSpPr>
+        <p:spPr>
+          <a:xfrm>
+            <a:off x="457200" y="6400800"/>
+            <a:ext cx="11277600" cy="15240"/>
+          </a:xfrm>
+          <a:prstGeom prst="rect">
+            <a:avLst/>
+          </a:prstGeom>
+          <a:solidFill>
+            <a:srgbClr val="E0261E"/>
+          </a:solidFill>
+          <a:ln>
+            <a:noFill/>
+          </a:ln>
+        </p:spPr>
+        <p:style>
+          <a:lnRef idx="1">
+            <a:schemeClr val="accent1"/>
+          </a:lnRef>
+          <a:fillRef idx="3">
+            <a:schemeClr val="accent1"/>
+          </a:fillRef>
+          <a:effectRef idx="2">
+            <a:schemeClr val="accent1"/>
+          </a:effectRef>
+          <a:fontRef idx="minor">
+            <a:schemeClr val="lt1"/>
+          </a:fontRef>
+        </p:style>
+        <p:txBody>
+          <a:bodyPr rtlCol="0" anchor="ctr"/>
+          <a:lstStyle/>
+          <a:p>
+            <a:pPr algn="ctr"/>
+          </a:p>
+        </p:txBody>
+      </p:sp>
+      <p:sp>
+        <p:nvSpPr>
+          <p:cNvPr id="32" name="TextBox 31"/>
+          <p:cNvSpPr txBox="1"/>
+          <p:nvPr/>
+        </p:nvSpPr>
+        <p:spPr>
+          <a:xfrm>
+            <a:off x="8200000" y="3520520"/>
+            <a:ext cx="3500000" cy="182880"/>
+          </a:xfrm>
+          <a:prstGeom prst="rect">
+            <a:avLst/>
+          </a:prstGeom>
+          <a:noFill/>
+        </p:spPr>
+        <p:txBody>
+          <a:bodyPr wrap="square" lIns="0" rIns="0" tIns="0" bIns="0" anchor="t">
+            <a:spAutoFit/>
+          </a:bodyPr>
+          <a:lstStyle/>
+          <a:p>
+            <a:pPr algn="l"/>
+            <a:r>
+              <a:rPr sz="800" b="0" i="1">
+                <a:solidFill>
+                  <a:srgbClr val="6B6B7A"/>
+                </a:solidFill>
+                <a:latin typeface="Arial"/>
+              </a:rPr>
+              <a:t>Base: Quadro 37 (Vieira, 2022 · p. 264)</a:t>
+            </a:r>
+          </a:p>
+        </p:txBody>
+      </p:sp>
+      <p:sp>
+        <p:nvSpPr>
+          <p:cNvPr id="33" name="TextBox 32"/>
+          <p:cNvSpPr txBox="1"/>
+          <p:nvPr/>
+        </p:nvSpPr>
+        <p:spPr>
+          <a:xfrm>
+            <a:off x="8200000" y="4206320"/>
+            <a:ext cx="3500000" cy="182880"/>
+          </a:xfrm>
+          <a:prstGeom prst="rect">
+            <a:avLst/>
+          </a:prstGeom>
+          <a:noFill/>
+        </p:spPr>
+        <p:txBody>
+          <a:bodyPr wrap="square" lIns="0" rIns="0" tIns="0" bIns="0" anchor="t">
+            <a:spAutoFit/>
+          </a:bodyPr>
+          <a:lstStyle/>
+          <a:p>
+            <a:pPr algn="l"/>
+            <a:r>
+              <a:rPr sz="800" b="0" i="1">
+                <a:solidFill>
+                  <a:srgbClr val="6B6B7A"/>
+                </a:solidFill>
+                <a:latin typeface="Arial"/>
+              </a:rPr>
+              <a:t>Referência: OPTI-PE (Vieira, 2022 · Cap. 5)</a:t>
+            </a:r>
+          </a:p>
+        </p:txBody>
+      </p:sp>
+      <p:sp>
+        <p:nvSpPr>
+          <p:cNvPr id="34" name="TextBox 33"/>
+          <p:cNvSpPr txBox="1"/>
+          <p:nvPr/>
+        </p:nvSpPr>
+        <p:spPr>
+          <a:xfrm>
+            <a:off x="8200000" y="4892120"/>
+            <a:ext cx="3500000" cy="182880"/>
+          </a:xfrm>
+          <a:prstGeom prst="rect">
+            <a:avLst/>
+          </a:prstGeom>
+          <a:noFill/>
+        </p:spPr>
+        <p:txBody>
+          <a:bodyPr wrap="square" lIns="0" rIns="0" tIns="0" bIns="0" anchor="t">
+            <a:spAutoFit/>
+          </a:bodyPr>
+          <a:lstStyle/>
+          <a:p>
+            <a:pPr algn="l"/>
+            <a:r>
+              <a:rPr sz="800" b="0" i="1">
+                <a:solidFill>
+                  <a:srgbClr val="6B6B7A"/>
+                </a:solidFill>
+                <a:latin typeface="Arial"/>
+              </a:rPr>
+              <a:t>Análise: levantamento de ferramentas de mercado</a:t>
+            </a:r>
+          </a:p>
+        </p:txBody>
+      </p:sp>
+      <p:sp>
+        <p:nvSpPr>
+          <p:cNvPr id="35" name="Rectangle 34"/>
+          <p:cNvSpPr/>
+          <p:nvPr/>
+        </p:nvSpPr>
+        <p:spPr>
+          <a:xfrm>
+            <a:off x="457200" y="6400800"/>
+            <a:ext cx="11277600" cy="15240"/>
+          </a:xfrm>
+          <a:prstGeom prst="rect">
+            <a:avLst/>
+          </a:prstGeom>
+          <a:solidFill>
+            <a:srgbClr val="E0261E"/>
+          </a:solidFill>
+          <a:ln>
+            <a:noFill/>
+          </a:ln>
+        </p:spPr>
+        <p:style>
+          <a:lnRef idx="1">
+            <a:schemeClr val="accent1"/>
+          </a:lnRef>
+          <a:fillRef idx="3">
+            <a:schemeClr val="accent1"/>
+          </a:fillRef>
+          <a:effectRef idx="2">
+            <a:schemeClr val="accent1"/>
+          </a:effectRef>
+          <a:fontRef idx="minor">
+            <a:schemeClr val="lt1"/>
+          </a:fontRef>
+        </p:style>
+        <p:txBody>
+          <a:bodyPr rtlCol="0" anchor="ctr"/>
+          <a:lstStyle/>
+          <a:p>
+            <a:pPr algn="ctr"/>
+          </a:p>
+        </p:txBody>
+      </p:sp>
+      <p:sp>
+        <p:nvSpPr>
+          <p:cNvPr id="36" name="TextBox 35"/>
+          <p:cNvSpPr txBox="1"/>
+          <p:nvPr/>
+        </p:nvSpPr>
+        <p:spPr>
+          <a:xfrm>
+            <a:off x="457200" y="6492240"/>
+            <a:ext cx="8000000" cy="228600"/>
+          </a:xfrm>
+          <a:prstGeom prst="rect">
+            <a:avLst/>
+          </a:prstGeom>
+          <a:noFill/>
+        </p:spPr>
+        <p:txBody>
+          <a:bodyPr wrap="square" lIns="0" rIns="0" tIns="0" bIns="0" anchor="t">
+            <a:spAutoFit/>
+          </a:bodyPr>
+          <a:lstStyle/>
+          <a:p>
+            <a:pPr algn="l"/>
+            <a:r>
+              <a:rPr sz="900" b="0" i="0">
+                <a:solidFill>
+                  <a:srgbClr val="6B6B7A"/>
+                </a:solidFill>
+                <a:latin typeface="Arial"/>
+              </a:rPr>
+              <a:t>Equipe ObiOne · UPE/POLI · Maio 2026</a:t>
+            </a:r>
+          </a:p>
+        </p:txBody>
+      </p:sp>
+      <p:sp>
+        <p:nvSpPr>
+          <p:cNvPr id="37" name="TextBox 36"/>
+          <p:cNvSpPr txBox="1"/>
+          <p:nvPr/>
+        </p:nvSpPr>
+        <p:spPr>
+          <a:xfrm>
+            <a:off x="11000000" y="6492240"/>
+            <a:ext cx="1000000" cy="228600"/>
+          </a:xfrm>
+          <a:prstGeom prst="rect">
+            <a:avLst/>
+          </a:prstGeom>
+          <a:noFill/>
+        </p:spPr>
+        <p:txBody>
+          <a:bodyPr wrap="square" lIns="0" rIns="0" tIns="0" bIns="0" anchor="t">
+            <a:spAutoFit/>
+          </a:bodyPr>
+          <a:lstStyle/>
+          <a:p>
+            <a:pPr algn="r"/>
+            <a:r>
+              <a:rPr sz="900" b="0" i="0">
+                <a:solidFill>
+                  <a:srgbClr val="6B6B7A"/>
+                </a:solidFill>
+                <a:latin typeface="Arial"/>
+              </a:rPr>
+              <a:t>4 / 8</a:t>
+            </a:r>
+          </a:p>
+        </p:txBody>
+      </p:sp>
+      <p:pic>
+        <p:nvPicPr>
+          <p:cNvPr id="38" name="Picture 37" descr="image.png"/>
+          <p:cNvPicPr>
+            <a:picLocks noChangeAspect="1"/>
+          </p:cNvPicPr>
+          <p:nvPr/>
+        </p:nvPicPr>
+        <p:blipFill>
+          <a:blip r:embed="rId2"/>
+          <a:stretch>
+            <a:fillRect/>
+          </a:stretch>
+        </p:blipFill>
+        <p:spPr>
+          <a:xfrm>
+            <a:off x="11000000" y="228600"/>
+            <a:ext cx="1066800" cy="801716"/>
+          </a:xfrm>
+          <a:prstGeom prst="rect">
+            <a:avLst/>
+          </a:prstGeom>
+        </p:spPr>
+      </p:pic>
     </p:spTree>
   </p:cSld>
   <p:clrMapOvr>

</xml_diff>

<commit_message>
Finaliza SR1: fix título slide 7 + speaker notes em todos os slides
- Slide 7: subtítulo "Sprint 0 concluído..." trocado por "Status atual e
  próximas semanas" (Sprint 0 não existe mais)
- Adiciona briefing de apresentação em cada um dos 8 slides via
  notes_slide.notes_text_frame: tempo estimado, falas-âncora, transições
  e perguntas prováveis (slide 8)

Co-Authored-By: Claude Opus 4.7 (1M context) <noreply@anthropic.com>
</commit_message>
<xml_diff>
--- a/atividades/apresentacoes/sr1_2026-05-22.pptx
+++ b/atividades/apresentacoes/sr1_2026-05-22.pptx
@@ -112,6 +112,1236 @@
     </a:lvl9pPr>
   </p:defaultTextStyle>
 </p:presentation>
+</file>
+
+<file path=ppt/notesMasters/notesMaster1.xml><?xml version="1.0" encoding="utf-8"?>
+<p:notesMaster xmlns:a="http://schemas.openxmlformats.org/drawingml/2006/main" xmlns:p="http://schemas.openxmlformats.org/presentationml/2006/main" xmlns:r="http://schemas.openxmlformats.org/officeDocument/2006/relationships">
+  <p:cSld>
+    <p:bg>
+      <p:bgRef idx="1001">
+        <a:schemeClr val="bg1"/>
+      </p:bgRef>
+    </p:bg>
+    <p:spTree>
+      <p:nvGrpSpPr>
+        <p:cNvPr id="1" name=""/>
+        <p:cNvGrpSpPr/>
+        <p:nvPr/>
+      </p:nvGrpSpPr>
+      <p:grpSpPr>
+        <a:xfrm>
+          <a:off x="0" y="0"/>
+          <a:ext cx="0" cy="0"/>
+          <a:chOff x="0" y="0"/>
+          <a:chExt cx="0" cy="0"/>
+        </a:xfrm>
+      </p:grpSpPr>
+      <p:sp>
+        <p:nvSpPr>
+          <p:cNvPr id="2" name="Header Placeholder 1"/>
+          <p:cNvSpPr>
+            <a:spLocks noGrp="1"/>
+          </p:cNvSpPr>
+          <p:nvPr>
+            <p:ph type="hdr" sz="quarter"/>
+          </p:nvPr>
+        </p:nvSpPr>
+        <p:spPr>
+          <a:xfrm>
+            <a:off x="0" y="0"/>
+            <a:ext cx="2971800" cy="457200"/>
+          </a:xfrm>
+          <a:prstGeom prst="rect">
+            <a:avLst/>
+          </a:prstGeom>
+        </p:spPr>
+        <p:txBody>
+          <a:bodyPr vert="horz" lIns="91440" tIns="45720" rIns="91440" bIns="45720" rtlCol="0"/>
+          <a:lstStyle>
+            <a:lvl1pPr algn="l">
+              <a:defRPr sz="1200"/>
+            </a:lvl1pPr>
+          </a:lstStyle>
+          <a:p>
+            <a:endParaRPr lang="en-US"/>
+          </a:p>
+        </p:txBody>
+      </p:sp>
+      <p:sp>
+        <p:nvSpPr>
+          <p:cNvPr id="3" name="Date Placeholder 2"/>
+          <p:cNvSpPr>
+            <a:spLocks noGrp="1"/>
+          </p:cNvSpPr>
+          <p:nvPr>
+            <p:ph type="dt" idx="1"/>
+          </p:nvPr>
+        </p:nvSpPr>
+        <p:spPr>
+          <a:xfrm>
+            <a:off x="3884613" y="0"/>
+            <a:ext cx="2971800" cy="457200"/>
+          </a:xfrm>
+          <a:prstGeom prst="rect">
+            <a:avLst/>
+          </a:prstGeom>
+        </p:spPr>
+        <p:txBody>
+          <a:bodyPr vert="horz" lIns="91440" tIns="45720" rIns="91440" bIns="45720" rtlCol="0"/>
+          <a:lstStyle>
+            <a:lvl1pPr algn="r">
+              <a:defRPr sz="1200"/>
+            </a:lvl1pPr>
+          </a:lstStyle>
+          <a:p>
+            <a:fld id="{0F89C1C7-3DCD-1040-A9CF-14679D8B5DDD}" type="datetimeFigureOut">
+              <a:rPr lang="en-US" smtClean="0"/>
+              <a:t>10/17/16</a:t>
+            </a:fld>
+            <a:endParaRPr lang="en-US"/>
+          </a:p>
+        </p:txBody>
+      </p:sp>
+      <p:sp>
+        <p:nvSpPr>
+          <p:cNvPr id="4" name="Slide Image Placeholder 3"/>
+          <p:cNvSpPr>
+            <a:spLocks noGrp="1" noRot="1" noChangeAspect="1"/>
+          </p:cNvSpPr>
+          <p:nvPr>
+            <p:ph type="sldImg" idx="2"/>
+          </p:nvPr>
+        </p:nvSpPr>
+        <p:spPr>
+          <a:xfrm>
+            <a:off x="1143000" y="685800"/>
+            <a:ext cx="4572000" cy="3429000"/>
+          </a:xfrm>
+          <a:prstGeom prst="rect">
+            <a:avLst/>
+          </a:prstGeom>
+          <a:noFill/>
+          <a:ln w="12700">
+            <a:solidFill>
+              <a:prstClr val="black"/>
+            </a:solidFill>
+          </a:ln>
+        </p:spPr>
+        <p:txBody>
+          <a:bodyPr vert="horz" lIns="91440" tIns="45720" rIns="91440" bIns="45720" rtlCol="0" anchor="ctr"/>
+          <a:lstStyle/>
+          <a:p>
+            <a:endParaRPr lang="en-US"/>
+          </a:p>
+        </p:txBody>
+      </p:sp>
+      <p:sp>
+        <p:nvSpPr>
+          <p:cNvPr id="5" name="Notes Placeholder 4"/>
+          <p:cNvSpPr>
+            <a:spLocks noGrp="1"/>
+          </p:cNvSpPr>
+          <p:nvPr>
+            <p:ph type="body" sz="quarter" idx="3"/>
+          </p:nvPr>
+        </p:nvSpPr>
+        <p:spPr>
+          <a:xfrm>
+            <a:off x="685800" y="4343400"/>
+            <a:ext cx="5486400" cy="4114800"/>
+          </a:xfrm>
+          <a:prstGeom prst="rect">
+            <a:avLst/>
+          </a:prstGeom>
+        </p:spPr>
+        <p:txBody>
+          <a:bodyPr vert="horz" lIns="91440" tIns="45720" rIns="91440" bIns="45720" rtlCol="0"/>
+          <a:lstStyle/>
+          <a:p>
+            <a:pPr lvl="0"/>
+            <a:r>
+              <a:rPr lang="en-US" smtClean="0"/>
+              <a:t>Click to edit Master text styles</a:t>
+            </a:r>
+          </a:p>
+          <a:p>
+            <a:pPr lvl="1"/>
+            <a:r>
+              <a:rPr lang="en-US" smtClean="0"/>
+              <a:t>Second level</a:t>
+            </a:r>
+          </a:p>
+          <a:p>
+            <a:pPr lvl="2"/>
+            <a:r>
+              <a:rPr lang="en-US" smtClean="0"/>
+              <a:t>Third level</a:t>
+            </a:r>
+          </a:p>
+          <a:p>
+            <a:pPr lvl="3"/>
+            <a:r>
+              <a:rPr lang="en-US" smtClean="0"/>
+              <a:t>Fourth level</a:t>
+            </a:r>
+          </a:p>
+          <a:p>
+            <a:pPr lvl="4"/>
+            <a:r>
+              <a:rPr lang="en-US" smtClean="0"/>
+              <a:t>Fifth level</a:t>
+            </a:r>
+            <a:endParaRPr lang="en-US"/>
+          </a:p>
+        </p:txBody>
+      </p:sp>
+      <p:sp>
+        <p:nvSpPr>
+          <p:cNvPr id="6" name="Footer Placeholder 5"/>
+          <p:cNvSpPr>
+            <a:spLocks noGrp="1"/>
+          </p:cNvSpPr>
+          <p:nvPr>
+            <p:ph type="ftr" sz="quarter" idx="4"/>
+          </p:nvPr>
+        </p:nvSpPr>
+        <p:spPr>
+          <a:xfrm>
+            <a:off x="0" y="8685213"/>
+            <a:ext cx="2971800" cy="457200"/>
+          </a:xfrm>
+          <a:prstGeom prst="rect">
+            <a:avLst/>
+          </a:prstGeom>
+        </p:spPr>
+        <p:txBody>
+          <a:bodyPr vert="horz" lIns="91440" tIns="45720" rIns="91440" bIns="45720" rtlCol="0" anchor="b"/>
+          <a:lstStyle>
+            <a:lvl1pPr algn="l">
+              <a:defRPr sz="1200"/>
+            </a:lvl1pPr>
+          </a:lstStyle>
+          <a:p>
+            <a:endParaRPr lang="en-US"/>
+          </a:p>
+        </p:txBody>
+      </p:sp>
+      <p:sp>
+        <p:nvSpPr>
+          <p:cNvPr id="7" name="Slide Number Placeholder 6"/>
+          <p:cNvSpPr>
+            <a:spLocks noGrp="1"/>
+          </p:cNvSpPr>
+          <p:nvPr>
+            <p:ph type="sldNum" sz="quarter" idx="5"/>
+          </p:nvPr>
+        </p:nvSpPr>
+        <p:spPr>
+          <a:xfrm>
+            <a:off x="3884613" y="8685213"/>
+            <a:ext cx="2971800" cy="457200"/>
+          </a:xfrm>
+          <a:prstGeom prst="rect">
+            <a:avLst/>
+          </a:prstGeom>
+        </p:spPr>
+        <p:txBody>
+          <a:bodyPr vert="horz" lIns="91440" tIns="45720" rIns="91440" bIns="45720" rtlCol="0" anchor="b"/>
+          <a:lstStyle>
+            <a:lvl1pPr algn="r">
+              <a:defRPr sz="1200"/>
+            </a:lvl1pPr>
+          </a:lstStyle>
+          <a:p>
+            <a:fld id="{BB5E49A5-4136-284D-997B-48E1D791AD67}" type="slidenum">
+              <a:rPr lang="en-US" smtClean="0"/>
+              <a:t>‹#›</a:t>
+            </a:fld>
+            <a:endParaRPr lang="en-US"/>
+          </a:p>
+        </p:txBody>
+      </p:sp>
+    </p:spTree>
+    <p:extLst>
+      <p:ext uri="{BB962C8B-B14F-4D97-AF65-F5344CB8AC3E}">
+        <p14:creationId xmlns:p14="http://schemas.microsoft.com/office/powerpoint/2010/main" val="2623252185"/>
+      </p:ext>
+    </p:extLst>
+  </p:cSld>
+  <p:clrMap bg1="lt1" tx1="dk1" bg2="lt2" tx2="dk2" accent1="accent1" accent2="accent2" accent3="accent3" accent4="accent4" accent5="accent5" accent6="accent6" hlink="hlink" folHlink="folHlink"/>
+  <p:notesStyle>
+    <a:lvl1pPr marL="0" algn="l" defTabSz="457200" rtl="0" eaLnBrk="1" latinLnBrk="0" hangingPunct="1">
+      <a:defRPr sz="1200" kern="1200">
+        <a:solidFill>
+          <a:schemeClr val="tx1"/>
+        </a:solidFill>
+        <a:latin typeface="+mn-lt"/>
+        <a:ea typeface="+mn-ea"/>
+        <a:cs typeface="+mn-cs"/>
+      </a:defRPr>
+    </a:lvl1pPr>
+    <a:lvl2pPr marL="457200" algn="l" defTabSz="457200" rtl="0" eaLnBrk="1" latinLnBrk="0" hangingPunct="1">
+      <a:defRPr sz="1200" kern="1200">
+        <a:solidFill>
+          <a:schemeClr val="tx1"/>
+        </a:solidFill>
+        <a:latin typeface="+mn-lt"/>
+        <a:ea typeface="+mn-ea"/>
+        <a:cs typeface="+mn-cs"/>
+      </a:defRPr>
+    </a:lvl2pPr>
+    <a:lvl3pPr marL="914400" algn="l" defTabSz="457200" rtl="0" eaLnBrk="1" latinLnBrk="0" hangingPunct="1">
+      <a:defRPr sz="1200" kern="1200">
+        <a:solidFill>
+          <a:schemeClr val="tx1"/>
+        </a:solidFill>
+        <a:latin typeface="+mn-lt"/>
+        <a:ea typeface="+mn-ea"/>
+        <a:cs typeface="+mn-cs"/>
+      </a:defRPr>
+    </a:lvl3pPr>
+    <a:lvl4pPr marL="1371600" algn="l" defTabSz="457200" rtl="0" eaLnBrk="1" latinLnBrk="0" hangingPunct="1">
+      <a:defRPr sz="1200" kern="1200">
+        <a:solidFill>
+          <a:schemeClr val="tx1"/>
+        </a:solidFill>
+        <a:latin typeface="+mn-lt"/>
+        <a:ea typeface="+mn-ea"/>
+        <a:cs typeface="+mn-cs"/>
+      </a:defRPr>
+    </a:lvl4pPr>
+    <a:lvl5pPr marL="1828800" algn="l" defTabSz="457200" rtl="0" eaLnBrk="1" latinLnBrk="0" hangingPunct="1">
+      <a:defRPr sz="1200" kern="1200">
+        <a:solidFill>
+          <a:schemeClr val="tx1"/>
+        </a:solidFill>
+        <a:latin typeface="+mn-lt"/>
+        <a:ea typeface="+mn-ea"/>
+        <a:cs typeface="+mn-cs"/>
+      </a:defRPr>
+    </a:lvl5pPr>
+    <a:lvl6pPr marL="2286000" algn="l" defTabSz="457200" rtl="0" eaLnBrk="1" latinLnBrk="0" hangingPunct="1">
+      <a:defRPr sz="1200" kern="1200">
+        <a:solidFill>
+          <a:schemeClr val="tx1"/>
+        </a:solidFill>
+        <a:latin typeface="+mn-lt"/>
+        <a:ea typeface="+mn-ea"/>
+        <a:cs typeface="+mn-cs"/>
+      </a:defRPr>
+    </a:lvl6pPr>
+    <a:lvl7pPr marL="2743200" algn="l" defTabSz="457200" rtl="0" eaLnBrk="1" latinLnBrk="0" hangingPunct="1">
+      <a:defRPr sz="1200" kern="1200">
+        <a:solidFill>
+          <a:schemeClr val="tx1"/>
+        </a:solidFill>
+        <a:latin typeface="+mn-lt"/>
+        <a:ea typeface="+mn-ea"/>
+        <a:cs typeface="+mn-cs"/>
+      </a:defRPr>
+    </a:lvl7pPr>
+    <a:lvl8pPr marL="3200400" algn="l" defTabSz="457200" rtl="0" eaLnBrk="1" latinLnBrk="0" hangingPunct="1">
+      <a:defRPr sz="1200" kern="1200">
+        <a:solidFill>
+          <a:schemeClr val="tx1"/>
+        </a:solidFill>
+        <a:latin typeface="+mn-lt"/>
+        <a:ea typeface="+mn-ea"/>
+        <a:cs typeface="+mn-cs"/>
+      </a:defRPr>
+    </a:lvl8pPr>
+    <a:lvl9pPr marL="3657600" algn="l" defTabSz="457200" rtl="0" eaLnBrk="1" latinLnBrk="0" hangingPunct="1">
+      <a:defRPr sz="1200" kern="1200">
+        <a:solidFill>
+          <a:schemeClr val="tx1"/>
+        </a:solidFill>
+        <a:latin typeface="+mn-lt"/>
+        <a:ea typeface="+mn-ea"/>
+        <a:cs typeface="+mn-cs"/>
+      </a:defRPr>
+    </a:lvl9pPr>
+  </p:notesStyle>
+</p:notesMaster>
+</file>
+
+<file path=ppt/notesSlides/notesSlide1.xml><?xml version="1.0" encoding="utf-8"?>
+<p:notes xmlns:a="http://schemas.openxmlformats.org/drawingml/2006/main" xmlns:p="http://schemas.openxmlformats.org/presentationml/2006/main" xmlns:r="http://schemas.openxmlformats.org/officeDocument/2006/relationships">
+  <p:cSld>
+    <p:spTree>
+      <p:nvGrpSpPr>
+        <p:cNvPr id="1" name=""/>
+        <p:cNvGrpSpPr/>
+        <p:nvPr/>
+      </p:nvGrpSpPr>
+      <p:grpSpPr>
+        <a:xfrm>
+          <a:off x="0" y="0"/>
+          <a:ext cx="0" cy="0"/>
+          <a:chOff x="0" y="0"/>
+          <a:chExt cx="0" cy="0"/>
+        </a:xfrm>
+      </p:grpSpPr>
+      <p:sp>
+        <p:nvSpPr>
+          <p:cNvPr id="2" name="Slide Image Placeholder 1"/>
+          <p:cNvSpPr>
+            <a:spLocks noGrp="1"/>
+          </p:cNvSpPr>
+          <p:nvPr>
+            <p:ph type="sldImg" idx="2"/>
+          </p:nvPr>
+        </p:nvSpPr>
+        <p:spPr/>
+      </p:sp>
+      <p:sp>
+        <p:nvSpPr>
+          <p:cNvPr id="3" name="Notes Placeholder 2"/>
+          <p:cNvSpPr>
+            <a:spLocks noGrp="1"/>
+          </p:cNvSpPr>
+          <p:nvPr>
+            <p:ph type="body" idx="3" sz="quarter"/>
+          </p:nvPr>
+        </p:nvSpPr>
+        <p:spPr/>
+        <p:txBody>
+          <a:bodyPr/>
+          <a:lstStyle/>
+          <a:p>
+            <a:r>
+              <a:t>[Tempo: ~30s]</a:t>
+            </a:r>
+          </a:p>
+          <a:p/>
+          <a:p>
+            <a:r>
+              <a:t>Saudação inicial. Apresentar o grupo e a cadeira:</a:t>
+            </a:r>
+          </a:p>
+          <a:p>
+            <a:r>
+              <a:t>"Somos Bruno, Cynthia, Moisés e Raniel, do grupo ObiOne, da cadeira Tópicos Avançados em Engenharia de Software, do prof. Ivaldir."</a:t>
+            </a:r>
+          </a:p>
+          <a:p/>
+          <a:p>
+            <a:r>
+              <a:t>Gancho: "Esse é o nosso Status Report 1. Vamos te mostrar o que é o ObiOne, o que vamos entregar até 10/07, e onde estamos agora."</a:t>
+            </a:r>
+          </a:p>
+        </p:txBody>
+      </p:sp>
+      <p:sp>
+        <p:nvSpPr>
+          <p:cNvPr id="4" name="Slide Number Placeholder 3"/>
+          <p:cNvSpPr>
+            <a:spLocks noGrp="1"/>
+          </p:cNvSpPr>
+          <p:nvPr>
+            <p:ph type="sldNum" idx="5" sz="quarter"/>
+          </p:nvPr>
+        </p:nvSpPr>
+        <p:spPr/>
+      </p:sp>
+    </p:spTree>
+  </p:cSld>
+  <p:clrMapOvr>
+    <a:masterClrMapping/>
+  </p:clrMapOvr>
+</p:notes>
+</file>
+
+<file path=ppt/notesSlides/notesSlide2.xml><?xml version="1.0" encoding="utf-8"?>
+<p:notes xmlns:a="http://schemas.openxmlformats.org/drawingml/2006/main" xmlns:p="http://schemas.openxmlformats.org/presentationml/2006/main" xmlns:r="http://schemas.openxmlformats.org/officeDocument/2006/relationships">
+  <p:cSld>
+    <p:spTree>
+      <p:nvGrpSpPr>
+        <p:cNvPr id="1" name=""/>
+        <p:cNvGrpSpPr/>
+        <p:nvPr/>
+      </p:nvGrpSpPr>
+      <p:grpSpPr>
+        <a:xfrm>
+          <a:off x="0" y="0"/>
+          <a:ext cx="0" cy="0"/>
+          <a:chOff x="0" y="0"/>
+          <a:chExt cx="0" cy="0"/>
+        </a:xfrm>
+      </p:grpSpPr>
+      <p:sp>
+        <p:nvSpPr>
+          <p:cNvPr id="2" name="Slide Image Placeholder 1"/>
+          <p:cNvSpPr>
+            <a:spLocks noGrp="1"/>
+          </p:cNvSpPr>
+          <p:nvPr>
+            <p:ph type="sldImg" idx="2"/>
+          </p:nvPr>
+        </p:nvSpPr>
+        <p:spPr/>
+      </p:sp>
+      <p:sp>
+        <p:nvSpPr>
+          <p:cNvPr id="3" name="Notes Placeholder 2"/>
+          <p:cNvSpPr>
+            <a:spLocks noGrp="1"/>
+          </p:cNvSpPr>
+          <p:nvPr>
+            <p:ph type="body" idx="3" sz="quarter"/>
+          </p:nvPr>
+        </p:nvSpPr>
+        <p:spPr/>
+        <p:txBody>
+          <a:bodyPr/>
+          <a:lstStyle/>
+          <a:p>
+            <a:r>
+              <a:t>[Tempo: ~30s]</a:t>
+            </a:r>
+          </a:p>
+          <a:p/>
+          <a:p>
+            <a:r>
+              <a:t>Apresente o roteiro em 4 blocos sem detalhar:</a:t>
+            </a:r>
+          </a:p>
+          <a:p>
+            <a:r>
+              <a:t>"Quatro partes: primeiro o contexto que motiva o projeto, depois o que vamos construir, o cronograma das 9 semanas restantes, e fechamos com o status atual."</a:t>
+            </a:r>
+          </a:p>
+        </p:txBody>
+      </p:sp>
+      <p:sp>
+        <p:nvSpPr>
+          <p:cNvPr id="4" name="Slide Number Placeholder 3"/>
+          <p:cNvSpPr>
+            <a:spLocks noGrp="1"/>
+          </p:cNvSpPr>
+          <p:nvPr>
+            <p:ph type="sldNum" idx="5" sz="quarter"/>
+          </p:nvPr>
+        </p:nvSpPr>
+        <p:spPr/>
+      </p:sp>
+    </p:spTree>
+  </p:cSld>
+  <p:clrMapOvr>
+    <a:masterClrMapping/>
+  </p:clrMapOvr>
+</p:notes>
+</file>
+
+<file path=ppt/notesSlides/notesSlide3.xml><?xml version="1.0" encoding="utf-8"?>
+<p:notes xmlns:a="http://schemas.openxmlformats.org/drawingml/2006/main" xmlns:p="http://schemas.openxmlformats.org/presentationml/2006/main" xmlns:r="http://schemas.openxmlformats.org/officeDocument/2006/relationships">
+  <p:cSld>
+    <p:spTree>
+      <p:nvGrpSpPr>
+        <p:cNvPr id="1" name=""/>
+        <p:cNvGrpSpPr/>
+        <p:nvPr/>
+      </p:nvGrpSpPr>
+      <p:grpSpPr>
+        <a:xfrm>
+          <a:off x="0" y="0"/>
+          <a:ext cx="0" cy="0"/>
+          <a:chOff x="0" y="0"/>
+          <a:chExt cx="0" cy="0"/>
+        </a:xfrm>
+      </p:grpSpPr>
+      <p:sp>
+        <p:nvSpPr>
+          <p:cNvPr id="2" name="Slide Image Placeholder 1"/>
+          <p:cNvSpPr>
+            <a:spLocks noGrp="1"/>
+          </p:cNvSpPr>
+          <p:nvPr>
+            <p:ph type="sldImg" idx="2"/>
+          </p:nvPr>
+        </p:nvSpPr>
+        <p:spPr/>
+      </p:sp>
+      <p:sp>
+        <p:nvSpPr>
+          <p:cNvPr id="3" name="Notes Placeholder 2"/>
+          <p:cNvSpPr>
+            <a:spLocks noGrp="1"/>
+          </p:cNvSpPr>
+          <p:nvPr>
+            <p:ph type="body" idx="3" sz="quarter"/>
+          </p:nvPr>
+        </p:nvSpPr>
+        <p:spPr/>
+        <p:txBody>
+          <a:bodyPr/>
+          <a:lstStyle/>
+          <a:p>
+            <a:r>
+              <a:t>[Tempo: ~2min — slide-chave para criar tensão narrativa]</a:t>
+            </a:r>
+          </a:p>
+          <a:p/>
+          <a:p>
+            <a:r>
+              <a:t>CARD ESQUERDO — "Observatórios vs. ferramentas":</a:t>
+            </a:r>
+          </a:p>
+          <a:p>
+            <a:r>
+              <a:t>"Observatório é MAIS que dashboard. É um espaço de conhecimento entre múltiplos atores — consultoria, clientes, pesquisa — mediado por interação contínua. Ferramentas de gestão como Jira ou planilhas só oferecem visualização de status. Falta o tecido social e a curadoria do conhecimento."</a:t>
+            </a:r>
+          </a:p>
+          <a:p/>
+          <a:p>
+            <a:r>
+              <a:t>TRANSIÇÃO para o card direito:</a:t>
+            </a:r>
+          </a:p>
+          <a:p>
+            <a:r>
+              <a:t>"Se observatórios são tão valiosos, por que são raros na prática? Porque mantê-los vivos é CARO."</a:t>
+            </a:r>
+          </a:p>
+          <a:p/>
+          <a:p>
+            <a:r>
+              <a:t>CARD DIREITO — três fontes de fricção:</a:t>
+            </a:r>
+          </a:p>
+          <a:p>
+            <a:r>
+              <a:t>1. Manual: ler .docx, estruturar, atualizar a curadoria de atributos</a:t>
+            </a:r>
+          </a:p>
+          <a:p>
+            <a:r>
+              <a:t>2. Repetitivo: comunicar progresso ao cliente em linguagem acessível</a:t>
+            </a:r>
+          </a:p>
+          <a:p>
+            <a:r>
+              <a:t>3. Custoso: manter engajamento da comunidade — responder, contextualizar</a:t>
+            </a:r>
+          </a:p>
+          <a:p/>
+          <a:p>
+            <a:r>
+              <a:t>FECHAMENTO: "Sem reduzir essa fricção, observatório fica restrito à teoria. É aí que entra a IA Generativa — e o ObiOne."</a:t>
+            </a:r>
+          </a:p>
+          <a:p/>
+          <a:p>
+            <a:r>
+              <a:t>Bases citadas: Vieira (2022) Cap. 5 (MPO); OPTI-PE como caso prático; Seção 6.4 sobre Trabalhos Futuros.</a:t>
+            </a:r>
+          </a:p>
+        </p:txBody>
+      </p:sp>
+      <p:sp>
+        <p:nvSpPr>
+          <p:cNvPr id="4" name="Slide Number Placeholder 3"/>
+          <p:cNvSpPr>
+            <a:spLocks noGrp="1"/>
+          </p:cNvSpPr>
+          <p:nvPr>
+            <p:ph type="sldNum" idx="5" sz="quarter"/>
+          </p:nvPr>
+        </p:nvSpPr>
+        <p:spPr/>
+      </p:sp>
+    </p:spTree>
+  </p:cSld>
+  <p:clrMapOvr>
+    <a:masterClrMapping/>
+  </p:clrMapOvr>
+</p:notes>
+</file>
+
+<file path=ppt/notesSlides/notesSlide4.xml><?xml version="1.0" encoding="utf-8"?>
+<p:notes xmlns:a="http://schemas.openxmlformats.org/drawingml/2006/main" xmlns:p="http://schemas.openxmlformats.org/presentationml/2006/main" xmlns:r="http://schemas.openxmlformats.org/officeDocument/2006/relationships">
+  <p:cSld>
+    <p:spTree>
+      <p:nvGrpSpPr>
+        <p:cNvPr id="1" name=""/>
+        <p:cNvGrpSpPr/>
+        <p:nvPr/>
+      </p:nvGrpSpPr>
+      <p:grpSpPr>
+        <a:xfrm>
+          <a:off x="0" y="0"/>
+          <a:ext cx="0" cy="0"/>
+          <a:chOff x="0" y="0"/>
+          <a:chExt cx="0" cy="0"/>
+        </a:xfrm>
+      </p:grpSpPr>
+      <p:sp>
+        <p:nvSpPr>
+          <p:cNvPr id="2" name="Slide Image Placeholder 1"/>
+          <p:cNvSpPr>
+            <a:spLocks noGrp="1"/>
+          </p:cNvSpPr>
+          <p:nvPr>
+            <p:ph type="sldImg" idx="2"/>
+          </p:nvPr>
+        </p:nvSpPr>
+        <p:spPr/>
+      </p:sp>
+      <p:sp>
+        <p:nvSpPr>
+          <p:cNvPr id="3" name="Notes Placeholder 2"/>
+          <p:cNvSpPr>
+            <a:spLocks noGrp="1"/>
+          </p:cNvSpPr>
+          <p:nvPr>
+            <p:ph type="body" idx="3" sz="quarter"/>
+          </p:nvPr>
+        </p:nvSpPr>
+        <p:spPr/>
+        <p:txBody>
+          <a:bodyPr/>
+          <a:lstStyle/>
+          <a:p>
+            <a:r>
+              <a:t>[Tempo: ~3min — NÚCLEO ESTRATÉGICO da apresentação]</a:t>
+            </a:r>
+          </a:p>
+          <a:p/>
+          <a:p>
+            <a:r>
+              <a:t>CARD ESQUERDO — "O que é o ObiOne":</a:t>
+            </a:r>
+          </a:p>
+          <a:p>
+            <a:r>
+              <a:t>Diga claramente: "O ObiOne é um observatório-de-portfólio para consultoria de projetos."</a:t>
+            </a:r>
+          </a:p>
+          <a:p/>
+          <a:p>
+            <a:r>
+              <a:t>PARA QUEM E PARA QUÊ — três audiências:</a:t>
+            </a:r>
+          </a:p>
+          <a:p>
+            <a:r>
+              <a:t>- CONSULTORIA: observa o portfólio como conhecimento estruturado, não como pasta de Drive.</a:t>
+            </a:r>
+          </a:p>
+          <a:p>
+            <a:r>
+              <a:t>- CLIENTE: acompanha o PRÓPRIO projeto em linguagem acessível, sem depender de reunião.</a:t>
+            </a:r>
+          </a:p>
+          <a:p>
+            <a:r>
+              <a:t>- COMUNIDADE vira ativo: comentários, comparativos cross-projeto, IA mantém o tecido vivo.</a:t>
+            </a:r>
+          </a:p>
+          <a:p/>
+          <a:p>
+            <a:r>
+              <a:t>PAUSA — deixe assentar.</a:t>
+            </a:r>
+          </a:p>
+          <a:p/>
+          <a:p>
+            <a:r>
+              <a:t>CARD DIREITO — "Por que isso é diferente do que já existe? Combinação inédita em 3 vetores":</a:t>
+            </a:r>
+          </a:p>
+          <a:p>
+            <a:r>
+              <a:t>- vs. PM (Jira, Trello, Asana): gerenciam tarefas e prazos. ObiOne OBSERVA o projeto como objeto de conhecimento, mapeando 44 atributos do MPO.</a:t>
+            </a:r>
+          </a:p>
+          <a:p>
+            <a:r>
+              <a:t>- vs. BI (Power BI, Looker): mostram métricas. ObiOne extrai SIGNIFICADO de .docx com LLM.</a:t>
+            </a:r>
+          </a:p>
+          <a:p>
+            <a:r>
+              <a:t>- vs. OBSERVATÓRIOS ACADÊMICOS (OPTI-PE): são instrumentos de pesquisa estáticos. ObiOne é OPERACIONAL — consultoria e clientes no dia-a-dia.</a:t>
+            </a:r>
+          </a:p>
+          <a:p/>
+          <a:p>
+            <a:r>
+              <a:t>FECHAMENTO: "Único a combinar observação MPO + extração com IA + comunidade ativa em uma só plataforma."</a:t>
+            </a:r>
+          </a:p>
+          <a:p/>
+          <a:p>
+            <a:r>
+              <a:t>Bases citadas: Quadro 37 do MPO (44 atributos); OPTI-PE (Vieira 2022 Cap. 5); levantamento de ferramentas de mercado.</a:t>
+            </a:r>
+          </a:p>
+        </p:txBody>
+      </p:sp>
+      <p:sp>
+        <p:nvSpPr>
+          <p:cNvPr id="4" name="Slide Number Placeholder 3"/>
+          <p:cNvSpPr>
+            <a:spLocks noGrp="1"/>
+          </p:cNvSpPr>
+          <p:nvPr>
+            <p:ph type="sldNum" idx="5" sz="quarter"/>
+          </p:nvPr>
+        </p:nvSpPr>
+        <p:spPr/>
+      </p:sp>
+    </p:spTree>
+  </p:cSld>
+  <p:clrMapOvr>
+    <a:masterClrMapping/>
+  </p:clrMapOvr>
+</p:notes>
+</file>
+
+<file path=ppt/notesSlides/notesSlide5.xml><?xml version="1.0" encoding="utf-8"?>
+<p:notes xmlns:a="http://schemas.openxmlformats.org/drawingml/2006/main" xmlns:p="http://schemas.openxmlformats.org/presentationml/2006/main" xmlns:r="http://schemas.openxmlformats.org/officeDocument/2006/relationships">
+  <p:cSld>
+    <p:spTree>
+      <p:nvGrpSpPr>
+        <p:cNvPr id="1" name=""/>
+        <p:cNvGrpSpPr/>
+        <p:nvPr/>
+      </p:nvGrpSpPr>
+      <p:grpSpPr>
+        <a:xfrm>
+          <a:off x="0" y="0"/>
+          <a:ext cx="0" cy="0"/>
+          <a:chOff x="0" y="0"/>
+          <a:chExt cx="0" cy="0"/>
+        </a:xfrm>
+      </p:grpSpPr>
+      <p:sp>
+        <p:nvSpPr>
+          <p:cNvPr id="2" name="Slide Image Placeholder 1"/>
+          <p:cNvSpPr>
+            <a:spLocks noGrp="1"/>
+          </p:cNvSpPr>
+          <p:nvPr>
+            <p:ph type="sldImg" idx="2"/>
+          </p:nvPr>
+        </p:nvSpPr>
+        <p:spPr/>
+      </p:sp>
+      <p:sp>
+        <p:nvSpPr>
+          <p:cNvPr id="3" name="Notes Placeholder 2"/>
+          <p:cNvSpPr>
+            <a:spLocks noGrp="1"/>
+          </p:cNvSpPr>
+          <p:nvPr>
+            <p:ph type="body" idx="3" sz="quarter"/>
+          </p:nvPr>
+        </p:nvSpPr>
+        <p:spPr/>
+        <p:txBody>
+          <a:bodyPr/>
+          <a:lstStyle/>
+          <a:p>
+            <a:r>
+              <a:t>[Tempo: ~2min]</a:t>
+            </a:r>
+          </a:p>
+          <a:p/>
+          <a:p>
+            <a:r>
+              <a:t>Descer ao nível da execução:</a:t>
+            </a:r>
+          </a:p>
+          <a:p>
+            <a:r>
+              <a:t>"Agora o como — escopo organizado em 5 grupos, 18 requisitos funcionais."</a:t>
+            </a:r>
+          </a:p>
+          <a:p/>
+          <a:p>
+            <a:r>
+              <a:t>Aponte para cada grupo brevemente (NÃO leia tudo):</a:t>
+            </a:r>
+          </a:p>
+          <a:p>
+            <a:r>
+              <a:t>- G1 PIPELINE LLM: extrai os 44 atributos via LLM, alimenta tudo</a:t>
+            </a:r>
+          </a:p>
+          <a:p>
+            <a:r>
+              <a:t>- G2 OBSERVAÇÃO: dashboard de cobertura — cliente vê apenas o seu projeto</a:t>
+            </a:r>
+          </a:p>
+          <a:p>
+            <a:r>
+              <a:t>- G3 COMUNIDADE: auth, perfis semi-abertos, comentários e feed</a:t>
+            </a:r>
+          </a:p>
+          <a:p>
+            <a:r>
+              <a:t>- G4 IA-ASSISTENTE: Resumo do Cliente (tradutora) + Drafts (redutora de fricção)</a:t>
+            </a:r>
+          </a:p>
+          <a:p>
+            <a:r>
+              <a:t>- G5 AVALIAÇÃO: rubrica + Cohen's Kappa nos 3 projetos + Likert × 2 audiências</a:t>
+            </a:r>
+          </a:p>
+          <a:p/>
+          <a:p>
+            <a:r>
+              <a:t>FECHAMENTO: "Cada grupo materializa uma categoria do MPO. Detalhes técnicos no repositório."</a:t>
+            </a:r>
+          </a:p>
+        </p:txBody>
+      </p:sp>
+      <p:sp>
+        <p:nvSpPr>
+          <p:cNvPr id="4" name="Slide Number Placeholder 3"/>
+          <p:cNvSpPr>
+            <a:spLocks noGrp="1"/>
+          </p:cNvSpPr>
+          <p:nvPr>
+            <p:ph type="sldNum" idx="5" sz="quarter"/>
+          </p:nvPr>
+        </p:nvSpPr>
+        <p:spPr/>
+      </p:sp>
+    </p:spTree>
+  </p:cSld>
+  <p:clrMapOvr>
+    <a:masterClrMapping/>
+  </p:clrMapOvr>
+</p:notes>
+</file>
+
+<file path=ppt/notesSlides/notesSlide6.xml><?xml version="1.0" encoding="utf-8"?>
+<p:notes xmlns:a="http://schemas.openxmlformats.org/drawingml/2006/main" xmlns:p="http://schemas.openxmlformats.org/presentationml/2006/main" xmlns:r="http://schemas.openxmlformats.org/officeDocument/2006/relationships">
+  <p:cSld>
+    <p:spTree>
+      <p:nvGrpSpPr>
+        <p:cNvPr id="1" name=""/>
+        <p:cNvGrpSpPr/>
+        <p:nvPr/>
+      </p:nvGrpSpPr>
+      <p:grpSpPr>
+        <a:xfrm>
+          <a:off x="0" y="0"/>
+          <a:ext cx="0" cy="0"/>
+          <a:chOff x="0" y="0"/>
+          <a:chExt cx="0" cy="0"/>
+        </a:xfrm>
+      </p:grpSpPr>
+      <p:sp>
+        <p:nvSpPr>
+          <p:cNvPr id="2" name="Slide Image Placeholder 1"/>
+          <p:cNvSpPr>
+            <a:spLocks noGrp="1"/>
+          </p:cNvSpPr>
+          <p:nvPr>
+            <p:ph type="sldImg" idx="2"/>
+          </p:nvPr>
+        </p:nvSpPr>
+        <p:spPr/>
+      </p:sp>
+      <p:sp>
+        <p:nvSpPr>
+          <p:cNvPr id="3" name="Notes Placeholder 2"/>
+          <p:cNvSpPr>
+            <a:spLocks noGrp="1"/>
+          </p:cNvSpPr>
+          <p:nvPr>
+            <p:ph type="body" idx="3" sz="quarter"/>
+          </p:nvPr>
+        </p:nvSpPr>
+        <p:spPr/>
+        <p:txBody>
+          <a:bodyPr/>
+          <a:lstStyle/>
+          <a:p>
+            <a:r>
+              <a:t>[Tempo: ~1.5min]</a:t>
+            </a:r>
+          </a:p>
+          <a:p/>
+          <a:p>
+            <a:r>
+              <a:t>"São 9 semanas até 10/07, divididas em 4 marcos."</a:t>
+            </a:r>
+          </a:p>
+          <a:p/>
+          <a:p>
+            <a:r>
+              <a:t>Percorra rapidamente os marcos (use os subtítulos como âncora):</a:t>
+            </a:r>
+          </a:p>
+          <a:p>
+            <a:r>
+              <a:t>- M1 PREPARAÇÃO (22-28 mai · ESTA SEMANA): atributos, protocolo, primeiros gabaritos. Destrava tudo o que vem.</a:t>
+            </a:r>
+          </a:p>
+          <a:p>
+            <a:r>
+              <a:t>- M2 PIPELINE (29 mai - 11 jun): núcleo técnico. Cadastro + upload + auth + extração LLM nos 5 projetos.</a:t>
+            </a:r>
+          </a:p>
+          <a:p>
+            <a:r>
+              <a:t>- M3 DASHBOARD + IA (12-25 jun): a comunidade ganha vida. Cobertura, perfis, comentários, Resumo do Cliente, Drafts assistidos. Status Report 2 em 19/06.</a:t>
+            </a:r>
+          </a:p>
+          <a:p>
+            <a:r>
+              <a:t>- M4 AVALIAÇÃO (26 jun - 2 jul): fecha o ciclo DSR. Precisão, Recall, F1, Kappa, Likert × 2.</a:t>
+            </a:r>
+          </a:p>
+          <a:p/>
+          <a:p>
+            <a:r>
+              <a:t>FECHAMENTO: "Escrita do relato de 3-9/07. Apresentação final em 10/07."</a:t>
+            </a:r>
+          </a:p>
+        </p:txBody>
+      </p:sp>
+      <p:sp>
+        <p:nvSpPr>
+          <p:cNvPr id="4" name="Slide Number Placeholder 3"/>
+          <p:cNvSpPr>
+            <a:spLocks noGrp="1"/>
+          </p:cNvSpPr>
+          <p:nvPr>
+            <p:ph type="sldNum" idx="5" sz="quarter"/>
+          </p:nvPr>
+        </p:nvSpPr>
+        <p:spPr/>
+      </p:sp>
+    </p:spTree>
+  </p:cSld>
+  <p:clrMapOvr>
+    <a:masterClrMapping/>
+  </p:clrMapOvr>
+</p:notes>
+</file>
+
+<file path=ppt/notesSlides/notesSlide7.xml><?xml version="1.0" encoding="utf-8"?>
+<p:notes xmlns:a="http://schemas.openxmlformats.org/drawingml/2006/main" xmlns:p="http://schemas.openxmlformats.org/presentationml/2006/main" xmlns:r="http://schemas.openxmlformats.org/officeDocument/2006/relationships">
+  <p:cSld>
+    <p:spTree>
+      <p:nvGrpSpPr>
+        <p:cNvPr id="1" name=""/>
+        <p:cNvGrpSpPr/>
+        <p:nvPr/>
+      </p:nvGrpSpPr>
+      <p:grpSpPr>
+        <a:xfrm>
+          <a:off x="0" y="0"/>
+          <a:ext cx="0" cy="0"/>
+          <a:chOff x="0" y="0"/>
+          <a:chExt cx="0" cy="0"/>
+        </a:xfrm>
+      </p:grpSpPr>
+      <p:sp>
+        <p:nvSpPr>
+          <p:cNvPr id="2" name="Slide Image Placeholder 1"/>
+          <p:cNvSpPr>
+            <a:spLocks noGrp="1"/>
+          </p:cNvSpPr>
+          <p:nvPr>
+            <p:ph type="sldImg" idx="2"/>
+          </p:nvPr>
+        </p:nvSpPr>
+        <p:spPr/>
+      </p:sp>
+      <p:sp>
+        <p:nvSpPr>
+          <p:cNvPr id="3" name="Notes Placeholder 2"/>
+          <p:cNvSpPr>
+            <a:spLocks noGrp="1"/>
+          </p:cNvSpPr>
+          <p:nvPr>
+            <p:ph type="body" idx="3" sz="quarter"/>
+          </p:nvPr>
+        </p:nvSpPr>
+        <p:spPr/>
+        <p:txBody>
+          <a:bodyPr/>
+          <a:lstStyle/>
+          <a:p>
+            <a:r>
+              <a:t>[Tempo: ~1.5min]</a:t>
+            </a:r>
+          </a:p>
+          <a:p/>
+          <a:p>
+            <a:r>
+              <a:t>"Onde estamos AGORA e o que vem nas próximas semanas."</a:t>
+            </a:r>
+          </a:p>
+          <a:p/>
+          <a:p>
+            <a:r>
+              <a:t>CARD ESQUERDO — ESTÁ FEITO (Sprint 1, esta semana — preparatória):</a:t>
+            </a:r>
+          </a:p>
+          <a:p>
+            <a:r>
+              <a:t>1. REQUISITOS: 18 funcionais + 9 não funcionais, em formato ficha</a:t>
+            </a:r>
+          </a:p>
+          <a:p>
+            <a:r>
+              <a:t>2. ATRIBUTOS-ALVO do MPO: os 44 do Quadro 37, categorizados por tipo</a:t>
+            </a:r>
+          </a:p>
+          <a:p>
+            <a:r>
+              <a:t>3. PROTOCOLO DE AVALIAÇÃO: rubrica híbrida 0/0,5/1 + Cohen's Kappa</a:t>
+            </a:r>
+          </a:p>
+          <a:p/>
+          <a:p>
+            <a:r>
+              <a:t>CARD DIREITO — PRÓXIMAS SEMANAS:</a:t>
+            </a:r>
+          </a:p>
+          <a:p>
+            <a:r>
+              <a:t>4. SPRINT 2 (22 mai - 4 jun): cadastro + upload + auth + pipeline LLM rodando nos 5 projetos</a:t>
+            </a:r>
+          </a:p>
+          <a:p>
+            <a:r>
+              <a:t>5. GABARITOS MANUAIS: Valença como piloto, depois Freire Batista e Kaka JJ — pareados (Cynthia + Moisés)</a:t>
+            </a:r>
+          </a:p>
+          <a:p>
+            <a:r>
+              <a:t>6. STATUS REPORT 2 (19/06): dashboard + IA-Assistente operacionais</a:t>
+            </a:r>
+          </a:p>
+        </p:txBody>
+      </p:sp>
+      <p:sp>
+        <p:nvSpPr>
+          <p:cNvPr id="4" name="Slide Number Placeholder 3"/>
+          <p:cNvSpPr>
+            <a:spLocks noGrp="1"/>
+          </p:cNvSpPr>
+          <p:nvPr>
+            <p:ph type="sldNum" idx="5" sz="quarter"/>
+          </p:nvPr>
+        </p:nvSpPr>
+        <p:spPr/>
+      </p:sp>
+    </p:spTree>
+  </p:cSld>
+  <p:clrMapOvr>
+    <a:masterClrMapping/>
+  </p:clrMapOvr>
+</p:notes>
+</file>
+
+<file path=ppt/notesSlides/notesSlide8.xml><?xml version="1.0" encoding="utf-8"?>
+<p:notes xmlns:a="http://schemas.openxmlformats.org/drawingml/2006/main" xmlns:p="http://schemas.openxmlformats.org/presentationml/2006/main" xmlns:r="http://schemas.openxmlformats.org/officeDocument/2006/relationships">
+  <p:cSld>
+    <p:spTree>
+      <p:nvGrpSpPr>
+        <p:cNvPr id="1" name=""/>
+        <p:cNvGrpSpPr/>
+        <p:nvPr/>
+      </p:nvGrpSpPr>
+      <p:grpSpPr>
+        <a:xfrm>
+          <a:off x="0" y="0"/>
+          <a:ext cx="0" cy="0"/>
+          <a:chOff x="0" y="0"/>
+          <a:chExt cx="0" cy="0"/>
+        </a:xfrm>
+      </p:grpSpPr>
+      <p:sp>
+        <p:nvSpPr>
+          <p:cNvPr id="2" name="Slide Image Placeholder 1"/>
+          <p:cNvSpPr>
+            <a:spLocks noGrp="1"/>
+          </p:cNvSpPr>
+          <p:nvPr>
+            <p:ph type="sldImg" idx="2"/>
+          </p:nvPr>
+        </p:nvSpPr>
+        <p:spPr/>
+      </p:sp>
+      <p:sp>
+        <p:nvSpPr>
+          <p:cNvPr id="3" name="Notes Placeholder 2"/>
+          <p:cNvSpPr>
+            <a:spLocks noGrp="1"/>
+          </p:cNvSpPr>
+          <p:nvPr>
+            <p:ph type="body" idx="3" sz="quarter"/>
+          </p:nvPr>
+        </p:nvSpPr>
+        <p:spPr/>
+        <p:txBody>
+          <a:bodyPr/>
+          <a:lstStyle/>
+          <a:p>
+            <a:r>
+              <a:t>[Tempo: ~30s + perguntas]</a:t>
+            </a:r>
+          </a:p>
+          <a:p/>
+          <a:p>
+            <a:r>
+              <a:t>"Esse foi nosso Status Report 1. Documentação completa no repositório raniel90/obione. Abrimos para perguntas."</a:t>
+            </a:r>
+          </a:p>
+          <a:p/>
+          <a:p>
+            <a:r>
+              <a:t>Antecipe perguntas prováveis (responda só se vierem):</a:t>
+            </a:r>
+          </a:p>
+          <a:p>
+            <a:r>
+              <a:t>- "Como vão validar o LLM?" → rubrica híbrida + 2 avaliadores independentes + Kappa</a:t>
+            </a:r>
+          </a:p>
+          <a:p>
+            <a:r>
+              <a:t>- "Quem são os clientes?" → consultoria parceira; 5 projetos reais de domínios distintos (jurídico, saúde, esporte, branding)</a:t>
+            </a:r>
+          </a:p>
+          <a:p>
+            <a:r>
+              <a:t>- "E se a IA errar?" → IA gera draft, consultor revisa antes de publicar</a:t>
+            </a:r>
+          </a:p>
+          <a:p>
+            <a:r>
+              <a:t>- "Por que LLM e não regex/parser?" → heterogeneidade dos .docx; LLM lida com variação semântica</a:t>
+            </a:r>
+          </a:p>
+        </p:txBody>
+      </p:sp>
+      <p:sp>
+        <p:nvSpPr>
+          <p:cNvPr id="4" name="Slide Number Placeholder 3"/>
+          <p:cNvSpPr>
+            <a:spLocks noGrp="1"/>
+          </p:cNvSpPr>
+          <p:nvPr>
+            <p:ph type="sldNum" idx="5" sz="quarter"/>
+          </p:nvPr>
+        </p:nvSpPr>
+        <p:spPr/>
+      </p:sp>
+    </p:spTree>
+  </p:cSld>
+  <p:clrMapOvr>
+    <a:masterClrMapping/>
+  </p:clrMapOvr>
+</p:notes>
 </file>
 
 <file path=ppt/slideLayouts/slideLayout1.xml><?xml version="1.0" encoding="utf-8"?>
@@ -9592,7 +10822,7 @@
                 </a:solidFill>
                 <a:latin typeface="Arial"/>
               </a:rPr>
-              <a:t>Sprint 0 concluído e próximas semanas</a:t>
+              <a:t>Status atual e próximas semanas</a:t>
             </a:r>
           </a:p>
         </p:txBody>
@@ -12552,4 +13782,324 @@
   </a:objectDefaults>
   <a:extraClrSchemeLst/>
 </a:theme>
+</file>
+
+<file path=ppt/theme/theme2.xml><?xml version="1.0" encoding="utf-8"?>
+<a:theme xmlns:a="http://schemas.openxmlformats.org/drawingml/2006/main" name="Office Theme">
+  <a:themeElements>
+    <a:clrScheme name="Office">
+      <a:dk1>
+        <a:sysClr val="windowText" lastClr="000000"/>
+      </a:dk1>
+      <a:lt1>
+        <a:sysClr val="window" lastClr="FFFFFF"/>
+      </a:lt1>
+      <a:dk2>
+        <a:srgbClr val="1F497D"/>
+      </a:dk2>
+      <a:lt2>
+        <a:srgbClr val="EEECE1"/>
+      </a:lt2>
+      <a:accent1>
+        <a:srgbClr val="4F81BD"/>
+      </a:accent1>
+      <a:accent2>
+        <a:srgbClr val="C0504D"/>
+      </a:accent2>
+      <a:accent3>
+        <a:srgbClr val="9BBB59"/>
+      </a:accent3>
+      <a:accent4>
+        <a:srgbClr val="8064A2"/>
+      </a:accent4>
+      <a:accent5>
+        <a:srgbClr val="4BACC6"/>
+      </a:accent5>
+      <a:accent6>
+        <a:srgbClr val="F79646"/>
+      </a:accent6>
+      <a:hlink>
+        <a:srgbClr val="0000FF"/>
+      </a:hlink>
+      <a:folHlink>
+        <a:srgbClr val="800080"/>
+      </a:folHlink>
+    </a:clrScheme>
+    <a:fontScheme name="Office">
+      <a:majorFont>
+        <a:latin typeface="Calibri"/>
+        <a:ea typeface=""/>
+        <a:cs typeface=""/>
+        <a:font script="Jpan" typeface="ＭＳ Ｐゴシック"/>
+        <a:font script="Hang" typeface="맑은 고딕"/>
+        <a:font script="Hans" typeface="宋体"/>
+        <a:font script="Hant" typeface="新細明體"/>
+        <a:font script="Arab" typeface="Times New Roman"/>
+        <a:font script="Hebr" typeface="Times New Roman"/>
+        <a:font script="Thai" typeface="Angsana New"/>
+        <a:font script="Ethi" typeface="Nyala"/>
+        <a:font script="Beng" typeface="Vrinda"/>
+        <a:font script="Gujr" typeface="Shruti"/>
+        <a:font script="Khmr" typeface="MoolBoran"/>
+        <a:font script="Knda" typeface="Tunga"/>
+        <a:font script="Guru" typeface="Raavi"/>
+        <a:font script="Cans" typeface="Euphemia"/>
+        <a:font script="Cher" typeface="Plantagenet Cherokee"/>
+        <a:font script="Yiii" typeface="Microsoft Yi Baiti"/>
+        <a:font script="Tibt" typeface="Microsoft Himalaya"/>
+        <a:font script="Thaa" typeface="MV Boli"/>
+        <a:font script="Deva" typeface="Mangal"/>
+        <a:font script="Telu" typeface="Gautami"/>
+        <a:font script="Taml" typeface="Latha"/>
+        <a:font script="Syrc" typeface="Estrangelo Edessa"/>
+        <a:font script="Orya" typeface="Kalinga"/>
+        <a:font script="Mlym" typeface="Kartika"/>
+        <a:font script="Laoo" typeface="DokChampa"/>
+        <a:font script="Sinh" typeface="Iskoola Pota"/>
+        <a:font script="Mong" typeface="Mongolian Baiti"/>
+        <a:font script="Viet" typeface="Times New Roman"/>
+        <a:font script="Uigh" typeface="Microsoft Uighur"/>
+        <a:font script="Geor" typeface="Sylfaen"/>
+      </a:majorFont>
+      <a:minorFont>
+        <a:latin typeface="Calibri"/>
+        <a:ea typeface=""/>
+        <a:cs typeface=""/>
+        <a:font script="Jpan" typeface="ＭＳ Ｐゴシック"/>
+        <a:font script="Hang" typeface="맑은 고딕"/>
+        <a:font script="Hans" typeface="宋体"/>
+        <a:font script="Hant" typeface="新細明體"/>
+        <a:font script="Arab" typeface="Arial"/>
+        <a:font script="Hebr" typeface="Arial"/>
+        <a:font script="Thai" typeface="Cordia New"/>
+        <a:font script="Ethi" typeface="Nyala"/>
+        <a:font script="Beng" typeface="Vrinda"/>
+        <a:font script="Gujr" typeface="Shruti"/>
+        <a:font script="Khmr" typeface="DaunPenh"/>
+        <a:font script="Knda" typeface="Tunga"/>
+        <a:font script="Guru" typeface="Raavi"/>
+        <a:font script="Cans" typeface="Euphemia"/>
+        <a:font script="Cher" typeface="Plantagenet Cherokee"/>
+        <a:font script="Yiii" typeface="Microsoft Yi Baiti"/>
+        <a:font script="Tibt" typeface="Microsoft Himalaya"/>
+        <a:font script="Thaa" typeface="MV Boli"/>
+        <a:font script="Deva" typeface="Mangal"/>
+        <a:font script="Telu" typeface="Gautami"/>
+        <a:font script="Taml" typeface="Latha"/>
+        <a:font script="Syrc" typeface="Estrangelo Edessa"/>
+        <a:font script="Orya" typeface="Kalinga"/>
+        <a:font script="Mlym" typeface="Kartika"/>
+        <a:font script="Laoo" typeface="DokChampa"/>
+        <a:font script="Sinh" typeface="Iskoola Pota"/>
+        <a:font script="Mong" typeface="Mongolian Baiti"/>
+        <a:font script="Viet" typeface="Arial"/>
+        <a:font script="Uigh" typeface="Microsoft Uighur"/>
+        <a:font script="Geor" typeface="Sylfaen"/>
+      </a:minorFont>
+    </a:fontScheme>
+    <a:fmtScheme name="Office">
+      <a:fillStyleLst>
+        <a:solidFill>
+          <a:schemeClr val="phClr"/>
+        </a:solidFill>
+        <a:gradFill rotWithShape="1">
+          <a:gsLst>
+            <a:gs pos="0">
+              <a:schemeClr val="phClr">
+                <a:tint val="50000"/>
+                <a:satMod val="300000"/>
+              </a:schemeClr>
+            </a:gs>
+            <a:gs pos="35000">
+              <a:schemeClr val="phClr">
+                <a:tint val="37000"/>
+                <a:satMod val="300000"/>
+              </a:schemeClr>
+            </a:gs>
+            <a:gs pos="100000">
+              <a:schemeClr val="phClr">
+                <a:tint val="15000"/>
+                <a:satMod val="350000"/>
+              </a:schemeClr>
+            </a:gs>
+          </a:gsLst>
+          <a:lin ang="16200000" scaled="1"/>
+        </a:gradFill>
+        <a:gradFill rotWithShape="1">
+          <a:gsLst>
+            <a:gs pos="0">
+              <a:schemeClr val="phClr">
+                <a:tint val="100000"/>
+                <a:shade val="100000"/>
+                <a:satMod val="130000"/>
+              </a:schemeClr>
+            </a:gs>
+            <a:gs pos="100000">
+              <a:schemeClr val="phClr">
+                <a:tint val="50000"/>
+                <a:shade val="100000"/>
+                <a:satMod val="350000"/>
+              </a:schemeClr>
+            </a:gs>
+          </a:gsLst>
+          <a:lin ang="16200000" scaled="0"/>
+        </a:gradFill>
+      </a:fillStyleLst>
+      <a:lnStyleLst>
+        <a:ln w="9525" cap="flat" cmpd="sng" algn="ctr">
+          <a:solidFill>
+            <a:schemeClr val="phClr">
+              <a:shade val="95000"/>
+              <a:satMod val="105000"/>
+            </a:schemeClr>
+          </a:solidFill>
+          <a:prstDash val="solid"/>
+        </a:ln>
+        <a:ln w="25400" cap="flat" cmpd="sng" algn="ctr">
+          <a:solidFill>
+            <a:schemeClr val="phClr"/>
+          </a:solidFill>
+          <a:prstDash val="solid"/>
+        </a:ln>
+        <a:ln w="38100" cap="flat" cmpd="sng" algn="ctr">
+          <a:solidFill>
+            <a:schemeClr val="phClr"/>
+          </a:solidFill>
+          <a:prstDash val="solid"/>
+        </a:ln>
+      </a:lnStyleLst>
+      <a:effectStyleLst>
+        <a:effectStyle>
+          <a:effectLst>
+            <a:outerShdw blurRad="40000" dist="20000" dir="5400000" rotWithShape="0">
+              <a:srgbClr val="000000">
+                <a:alpha val="38000"/>
+              </a:srgbClr>
+            </a:outerShdw>
+          </a:effectLst>
+        </a:effectStyle>
+        <a:effectStyle>
+          <a:effectLst>
+            <a:outerShdw blurRad="40000" dist="23000" dir="5400000" rotWithShape="0">
+              <a:srgbClr val="000000">
+                <a:alpha val="35000"/>
+              </a:srgbClr>
+            </a:outerShdw>
+          </a:effectLst>
+        </a:effectStyle>
+        <a:effectStyle>
+          <a:effectLst>
+            <a:outerShdw blurRad="40000" dist="23000" dir="5400000" rotWithShape="0">
+              <a:srgbClr val="000000">
+                <a:alpha val="35000"/>
+              </a:srgbClr>
+            </a:outerShdw>
+          </a:effectLst>
+          <a:scene3d>
+            <a:camera prst="orthographicFront">
+              <a:rot lat="0" lon="0" rev="0"/>
+            </a:camera>
+            <a:lightRig rig="threePt" dir="t">
+              <a:rot lat="0" lon="0" rev="1200000"/>
+            </a:lightRig>
+          </a:scene3d>
+          <a:sp3d>
+            <a:bevelT w="63500" h="25400"/>
+          </a:sp3d>
+        </a:effectStyle>
+      </a:effectStyleLst>
+      <a:bgFillStyleLst>
+        <a:solidFill>
+          <a:schemeClr val="phClr"/>
+        </a:solidFill>
+        <a:gradFill rotWithShape="1">
+          <a:gsLst>
+            <a:gs pos="0">
+              <a:schemeClr val="phClr">
+                <a:tint val="40000"/>
+                <a:satMod val="350000"/>
+              </a:schemeClr>
+            </a:gs>
+            <a:gs pos="40000">
+              <a:schemeClr val="phClr">
+                <a:tint val="45000"/>
+                <a:shade val="99000"/>
+                <a:satMod val="350000"/>
+              </a:schemeClr>
+            </a:gs>
+            <a:gs pos="100000">
+              <a:schemeClr val="phClr">
+                <a:shade val="20000"/>
+                <a:satMod val="255000"/>
+              </a:schemeClr>
+            </a:gs>
+          </a:gsLst>
+          <a:path path="circle">
+            <a:fillToRect l="50000" t="-80000" r="50000" b="180000"/>
+          </a:path>
+        </a:gradFill>
+        <a:gradFill rotWithShape="1">
+          <a:gsLst>
+            <a:gs pos="0">
+              <a:schemeClr val="phClr">
+                <a:tint val="80000"/>
+                <a:satMod val="300000"/>
+              </a:schemeClr>
+            </a:gs>
+            <a:gs pos="100000">
+              <a:schemeClr val="phClr">
+                <a:shade val="30000"/>
+                <a:satMod val="200000"/>
+              </a:schemeClr>
+            </a:gs>
+          </a:gsLst>
+          <a:path path="circle">
+            <a:fillToRect l="50000" t="50000" r="50000" b="50000"/>
+          </a:path>
+        </a:gradFill>
+      </a:bgFillStyleLst>
+    </a:fmtScheme>
+  </a:themeElements>
+  <a:objectDefaults>
+    <a:spDef>
+      <a:spPr/>
+      <a:bodyPr/>
+      <a:lstStyle/>
+      <a:style>
+        <a:lnRef idx="1">
+          <a:schemeClr val="accent1"/>
+        </a:lnRef>
+        <a:fillRef idx="3">
+          <a:schemeClr val="accent1"/>
+        </a:fillRef>
+        <a:effectRef idx="2">
+          <a:schemeClr val="accent1"/>
+        </a:effectRef>
+        <a:fontRef idx="minor">
+          <a:schemeClr val="lt1"/>
+        </a:fontRef>
+      </a:style>
+    </a:spDef>
+    <a:lnDef>
+      <a:spPr/>
+      <a:bodyPr/>
+      <a:lstStyle/>
+      <a:style>
+        <a:lnRef idx="2">
+          <a:schemeClr val="accent1"/>
+        </a:lnRef>
+        <a:fillRef idx="0">
+          <a:schemeClr val="accent1"/>
+        </a:fillRef>
+        <a:effectRef idx="1">
+          <a:schemeClr val="accent1"/>
+        </a:effectRef>
+        <a:fontRef idx="minor">
+          <a:schemeClr val="tx1"/>
+        </a:fontRef>
+      </a:style>
+    </a:lnDef>
+  </a:objectDefaults>
+  <a:extraClrSchemeLst/>
+</a:theme>
 </file>
</xml_diff>